<commit_message>
added documents before submission on cavnas
</commit_message>
<xml_diff>
--- a/submissions/presentation/Miller_Zins_Presentation.pptx
+++ b/submissions/presentation/Miller_Zins_Presentation.pptx
@@ -13,16 +13,16 @@
   <p:sldIdLst>
     <p:sldId id="256" r:id="rId2"/>
     <p:sldId id="257" r:id="rId3"/>
-    <p:sldId id="258" r:id="rId4"/>
-    <p:sldId id="265" r:id="rId5"/>
-    <p:sldId id="259" r:id="rId6"/>
-    <p:sldId id="260" r:id="rId7"/>
-    <p:sldId id="261" r:id="rId8"/>
-    <p:sldId id="267" r:id="rId9"/>
-    <p:sldId id="268" r:id="rId10"/>
-    <p:sldId id="263" r:id="rId11"/>
-    <p:sldId id="266" r:id="rId12"/>
-    <p:sldId id="264" r:id="rId13"/>
+    <p:sldId id="265" r:id="rId4"/>
+    <p:sldId id="259" r:id="rId5"/>
+    <p:sldId id="260" r:id="rId6"/>
+    <p:sldId id="261" r:id="rId7"/>
+    <p:sldId id="272" r:id="rId8"/>
+    <p:sldId id="271" r:id="rId9"/>
+    <p:sldId id="270" r:id="rId10"/>
+    <p:sldId id="266" r:id="rId11"/>
+    <p:sldId id="264" r:id="rId12"/>
+    <p:sldId id="273" r:id="rId13"/>
   </p:sldIdLst>
   <p:sldSz cx="12192000" cy="6858000"/>
   <p:notesSz cx="9144000" cy="6858000"/>
@@ -170,17 +170,20 @@
           <p14:sldIdLst>
             <p14:sldId id="256"/>
             <p14:sldId id="257"/>
-            <p14:sldId id="258"/>
             <p14:sldId id="265"/>
             <p14:sldId id="259"/>
             <p14:sldId id="260"/>
             <p14:sldId id="261"/>
-            <p14:sldId id="267"/>
-            <p14:sldId id="268"/>
-            <p14:sldId id="263"/>
+            <p14:sldId id="272"/>
+            <p14:sldId id="271"/>
+            <p14:sldId id="270"/>
             <p14:sldId id="266"/>
             <p14:sldId id="264"/>
+            <p14:sldId id="273"/>
           </p14:sldIdLst>
+        </p14:section>
+        <p14:section name="Default Section" id="{65B022AA-209E-473B-A4E6-56285D175B06}">
+          <p14:sldIdLst/>
         </p14:section>
       </p14:sectionLst>
     </p:ext>
@@ -293,7 +296,7 @@
           <a:p>
             <a:fld id="{6D72FF73-3B8F-A544-A0A0-42F2B80C88BC}" type="datetimeFigureOut">
               <a:rPr lang="en-US" smtClean="0"/>
-              <a:t>11/20/2025</a:t>
+              <a:t>11/21/2025</a:t>
             </a:fld>
             <a:endParaRPr lang="en-US" dirty="0"/>
           </a:p>
@@ -2639,126 +2642,6 @@
         <p:cNvPr id="1" name="">
           <a:extLst>
             <a:ext uri="{FF2B5EF4-FFF2-40B4-BE49-F238E27FC236}">
-              <a16:creationId xmlns:a16="http://schemas.microsoft.com/office/drawing/2014/main" id="{98A7B22B-B828-444D-3A85-EB3E52ED6746}"/>
-            </a:ext>
-          </a:extLst>
-        </p:cNvPr>
-        <p:cNvGrpSpPr/>
-        <p:nvPr/>
-      </p:nvGrpSpPr>
-      <p:grpSpPr>
-        <a:xfrm>
-          <a:off x="0" y="0"/>
-          <a:ext cx="0" cy="0"/>
-          <a:chOff x="0" y="0"/>
-          <a:chExt cx="0" cy="0"/>
-        </a:xfrm>
-      </p:grpSpPr>
-      <p:sp>
-        <p:nvSpPr>
-          <p:cNvPr id="2" name="Title 1">
-            <a:extLst>
-              <a:ext uri="{FF2B5EF4-FFF2-40B4-BE49-F238E27FC236}">
-                <a16:creationId xmlns:a16="http://schemas.microsoft.com/office/drawing/2014/main" id="{6863F9C3-1EE4-FA2A-B322-B7A8484E4EF4}"/>
-              </a:ext>
-            </a:extLst>
-          </p:cNvPr>
-          <p:cNvSpPr>
-            <a:spLocks noGrp="1"/>
-          </p:cNvSpPr>
-          <p:nvPr>
-            <p:ph type="title"/>
-          </p:nvPr>
-        </p:nvSpPr>
-        <p:spPr/>
-        <p:txBody>
-          <a:bodyPr/>
-          <a:lstStyle/>
-          <a:p>
-            <a:r>
-              <a:rPr lang="en-US" dirty="0"/>
-              <a:t>Results</a:t>
-            </a:r>
-          </a:p>
-        </p:txBody>
-      </p:sp>
-      <p:sp>
-        <p:nvSpPr>
-          <p:cNvPr id="3" name="Slide Number Placeholder 2">
-            <a:extLst>
-              <a:ext uri="{FF2B5EF4-FFF2-40B4-BE49-F238E27FC236}">
-                <a16:creationId xmlns:a16="http://schemas.microsoft.com/office/drawing/2014/main" id="{0C21D1E0-5B3A-5016-9B3F-2E1D2F79F8D5}"/>
-              </a:ext>
-            </a:extLst>
-          </p:cNvPr>
-          <p:cNvSpPr>
-            <a:spLocks noGrp="1"/>
-          </p:cNvSpPr>
-          <p:nvPr>
-            <p:ph type="sldNum" sz="quarter" idx="10"/>
-          </p:nvPr>
-        </p:nvSpPr>
-        <p:spPr/>
-        <p:txBody>
-          <a:bodyPr/>
-          <a:lstStyle/>
-          <a:p>
-            <a:fld id="{CAC3FE34-2808-40E6-BEA2-B7CA77D47CA5}" type="slidenum">
-              <a:rPr lang="en-US" smtClean="0"/>
-              <a:pPr/>
-              <a:t>10</a:t>
-            </a:fld>
-            <a:endParaRPr lang="en-US" dirty="0"/>
-          </a:p>
-        </p:txBody>
-      </p:sp>
-      <p:sp>
-        <p:nvSpPr>
-          <p:cNvPr id="4" name="Text Placeholder 3">
-            <a:extLst>
-              <a:ext uri="{FF2B5EF4-FFF2-40B4-BE49-F238E27FC236}">
-                <a16:creationId xmlns:a16="http://schemas.microsoft.com/office/drawing/2014/main" id="{F4DBB3EB-9DCC-9097-A662-2582FF071136}"/>
-              </a:ext>
-            </a:extLst>
-          </p:cNvPr>
-          <p:cNvSpPr>
-            <a:spLocks noGrp="1"/>
-          </p:cNvSpPr>
-          <p:nvPr>
-            <p:ph type="body" sz="quarter" idx="11"/>
-          </p:nvPr>
-        </p:nvSpPr>
-        <p:spPr/>
-        <p:txBody>
-          <a:bodyPr/>
-          <a:lstStyle/>
-          <a:p>
-            <a:endParaRPr lang="en-US"/>
-          </a:p>
-        </p:txBody>
-      </p:sp>
-    </p:spTree>
-    <p:extLst>
-      <p:ext uri="{BB962C8B-B14F-4D97-AF65-F5344CB8AC3E}">
-        <p14:creationId xmlns:p14="http://schemas.microsoft.com/office/powerpoint/2010/main" val="537230882"/>
-      </p:ext>
-    </p:extLst>
-  </p:cSld>
-  <p:clrMapOvr>
-    <a:masterClrMapping/>
-  </p:clrMapOvr>
-  <p:transition spd="med"/>
-</p:sld>
-</file>
-
-<file path=ppt/slides/slide11.xml><?xml version="1.0" encoding="utf-8"?>
-<p:sld xmlns:a="http://schemas.openxmlformats.org/drawingml/2006/main" xmlns:r="http://schemas.openxmlformats.org/officeDocument/2006/relationships" xmlns:p="http://schemas.openxmlformats.org/presentationml/2006/main">
-  <p:cSld>
-    <p:spTree>
-      <p:nvGrpSpPr>
-        <p:cNvPr id="1" name="">
-          <a:extLst>
-            <a:ext uri="{FF2B5EF4-FFF2-40B4-BE49-F238E27FC236}">
               <a16:creationId xmlns:a16="http://schemas.microsoft.com/office/drawing/2014/main" id="{31D71018-4EB8-B688-7CAA-667E8F2C2647}"/>
             </a:ext>
           </a:extLst>
@@ -2774,6 +2657,130 @@
           <a:chExt cx="0" cy="0"/>
         </a:xfrm>
       </p:grpSpPr>
+      <p:pic>
+        <p:nvPicPr>
+          <p:cNvPr id="8" name="Picture 7" descr="A graph of a distribution of 3d error&#10;&#10;AI-generated content may be incorrect.">
+            <a:extLst>
+              <a:ext uri="{FF2B5EF4-FFF2-40B4-BE49-F238E27FC236}">
+                <a16:creationId xmlns:a16="http://schemas.microsoft.com/office/drawing/2014/main" id="{4E81D92F-0CF4-B49A-0892-3FF38417B6F5}"/>
+              </a:ext>
+            </a:extLst>
+          </p:cNvPr>
+          <p:cNvPicPr>
+            <a:picLocks noChangeAspect="1"/>
+          </p:cNvPicPr>
+          <p:nvPr/>
+        </p:nvPicPr>
+        <p:blipFill>
+          <a:blip r:embed="rId2">
+            <a:extLst>
+              <a:ext uri="{28A0092B-C50C-407E-A947-70E740481C1C}">
+                <a14:useLocalDpi xmlns:a14="http://schemas.microsoft.com/office/drawing/2010/main" val="0"/>
+              </a:ext>
+            </a:extLst>
+          </a:blip>
+          <a:stretch>
+            <a:fillRect/>
+          </a:stretch>
+        </p:blipFill>
+        <p:spPr>
+          <a:xfrm>
+            <a:off x="7325598" y="2589924"/>
+            <a:ext cx="3992887" cy="2495554"/>
+          </a:xfrm>
+          <a:prstGeom prst="rect">
+            <a:avLst/>
+          </a:prstGeom>
+        </p:spPr>
+      </p:pic>
+      <p:sp>
+        <p:nvSpPr>
+          <p:cNvPr id="6" name="Rectangle 5">
+            <a:extLst>
+              <a:ext uri="{FF2B5EF4-FFF2-40B4-BE49-F238E27FC236}">
+                <a16:creationId xmlns:a16="http://schemas.microsoft.com/office/drawing/2014/main" id="{63C2E01A-1675-C424-2D5C-990DA2D074AC}"/>
+              </a:ext>
+            </a:extLst>
+          </p:cNvPr>
+          <p:cNvSpPr/>
+          <p:nvPr/>
+        </p:nvSpPr>
+        <p:spPr>
+          <a:xfrm>
+            <a:off x="10542202" y="5412565"/>
+            <a:ext cx="1552575" cy="1390650"/>
+          </a:xfrm>
+          <a:prstGeom prst="rect">
+            <a:avLst/>
+          </a:prstGeom>
+          <a:solidFill>
+            <a:schemeClr val="bg1"/>
+          </a:solidFill>
+          <a:ln w="12700" cap="flat">
+            <a:noFill/>
+            <a:miter lim="400000"/>
+          </a:ln>
+          <a:effectLst/>
+        </p:spPr>
+        <p:style>
+          <a:lnRef idx="0">
+            <a:scrgbClr r="0" g="0" b="0"/>
+          </a:lnRef>
+          <a:fillRef idx="0">
+            <a:scrgbClr r="0" g="0" b="0"/>
+          </a:fillRef>
+          <a:effectRef idx="0">
+            <a:scrgbClr r="0" g="0" b="0"/>
+          </a:effectRef>
+          <a:fontRef idx="none"/>
+        </p:style>
+        <p:txBody>
+          <a:bodyPr rot="0" spcFirstLastPara="1" vertOverflow="overflow" horzOverflow="overflow" vert="horz" wrap="square" lIns="50800" tIns="50800" rIns="50800" bIns="50800" numCol="1" spcCol="38100" rtlCol="0" anchor="ctr">
+            <a:spAutoFit/>
+          </a:bodyPr>
+          <a:lstStyle/>
+          <a:p>
+            <a:pPr marL="0" marR="0" indent="0" algn="ctr" defTabSz="584200" rtl="0" fontAlgn="auto" latinLnBrk="1" hangingPunct="0">
+              <a:lnSpc>
+                <a:spcPct val="100000"/>
+              </a:lnSpc>
+              <a:spcBef>
+                <a:spcPts val="0"/>
+              </a:spcBef>
+              <a:spcAft>
+                <a:spcPts val="0"/>
+              </a:spcAft>
+              <a:buClr>
+                <a:srgbClr val="000000"/>
+              </a:buClr>
+              <a:buSzTx/>
+              <a:buFont typeface="Calibri"/>
+              <a:buNone/>
+              <a:tabLst/>
+            </a:pPr>
+            <a:endParaRPr kumimoji="0" lang="en-US" sz="4000" b="0" i="0" u="none" strike="noStrike" cap="none" spc="0" normalizeH="0" baseline="0">
+              <a:ln>
+                <a:noFill/>
+              </a:ln>
+              <a:solidFill>
+                <a:srgbClr val="FFFFFF"/>
+              </a:solidFill>
+              <a:effectLst>
+                <a:outerShdw blurRad="38100" dist="12700" dir="5400000" rotWithShape="0">
+                  <a:srgbClr val="000000">
+                    <a:alpha val="50000"/>
+                  </a:srgbClr>
+                </a:outerShdw>
+              </a:effectLst>
+              <a:uFillTx/>
+              <a:latin typeface="+mn-lt"/>
+              <a:ea typeface="+mn-ea"/>
+              <a:cs typeface="+mn-cs"/>
+              <a:sym typeface="Calibri"/>
+            </a:endParaRPr>
+          </a:p>
+        </p:txBody>
+      </p:sp>
       <p:sp>
         <p:nvSpPr>
           <p:cNvPr id="2" name="Title 1">
@@ -2826,7 +2833,7 @@
             <a:fld id="{CAC3FE34-2808-40E6-BEA2-B7CA77D47CA5}" type="slidenum">
               <a:rPr lang="en-US" smtClean="0"/>
               <a:pPr/>
-              <a:t>11</a:t>
+              <a:t>10</a:t>
             </a:fld>
             <a:endParaRPr lang="en-US" dirty="0"/>
           </a:p>
@@ -2848,12 +2855,586 @@
             <p:ph type="body" sz="quarter" idx="11"/>
           </p:nvPr>
         </p:nvSpPr>
-        <p:spPr/>
+        <p:spPr>
+          <a:xfrm>
+            <a:off x="135539" y="1341438"/>
+            <a:ext cx="7544767" cy="5461777"/>
+          </a:xfrm>
+        </p:spPr>
         <p:txBody>
           <a:bodyPr/>
           <a:lstStyle/>
           <a:p>
-            <a:endParaRPr lang="en-US"/>
+            <a:r>
+              <a:rPr lang="en-US" dirty="0"/>
+              <a:t>The designed TDNN was able to provide a %45.40 improvement over the traditional SGP4 orbit propagation</a:t>
+            </a:r>
+          </a:p>
+          <a:p>
+            <a:r>
+              <a:rPr lang="en-US" dirty="0"/>
+              <a:t>The distribution of the model errors appears to be gaussian, with the TDNN decreasing mean and variance when compared to SGP4</a:t>
+            </a:r>
+          </a:p>
+          <a:p>
+            <a:pPr marL="0" indent="0">
+              <a:buNone/>
+            </a:pPr>
+            <a:endParaRPr lang="en-US" dirty="0"/>
+          </a:p>
+        </p:txBody>
+      </p:sp>
+      <p:pic>
+        <p:nvPicPr>
+          <p:cNvPr id="14" name="Picture 13" descr="A graph with a blue line&#10;&#10;AI-generated content may be incorrect.">
+            <a:extLst>
+              <a:ext uri="{FF2B5EF4-FFF2-40B4-BE49-F238E27FC236}">
+                <a16:creationId xmlns:a16="http://schemas.microsoft.com/office/drawing/2014/main" id="{80C08060-AF92-DA15-1CAD-9E70E740D7FD}"/>
+              </a:ext>
+            </a:extLst>
+          </p:cNvPr>
+          <p:cNvPicPr>
+            <a:picLocks noChangeAspect="1"/>
+          </p:cNvPicPr>
+          <p:nvPr/>
+        </p:nvPicPr>
+        <p:blipFill>
+          <a:blip r:embed="rId3" cstate="print">
+            <a:extLst>
+              <a:ext uri="{28A0092B-C50C-407E-A947-70E740481C1C}">
+                <a14:useLocalDpi xmlns:a14="http://schemas.microsoft.com/office/drawing/2010/main" val="0"/>
+              </a:ext>
+            </a:extLst>
+          </a:blip>
+          <a:stretch>
+            <a:fillRect/>
+          </a:stretch>
+        </p:blipFill>
+        <p:spPr>
+          <a:xfrm>
+            <a:off x="6612475" y="5144246"/>
+            <a:ext cx="5419135" cy="1600201"/>
+          </a:xfrm>
+          <a:prstGeom prst="rect">
+            <a:avLst/>
+          </a:prstGeom>
+        </p:spPr>
+      </p:pic>
+      <p:graphicFrame>
+        <p:nvGraphicFramePr>
+          <p:cNvPr id="5" name="Table 4">
+            <a:extLst>
+              <a:ext uri="{FF2B5EF4-FFF2-40B4-BE49-F238E27FC236}">
+                <a16:creationId xmlns:a16="http://schemas.microsoft.com/office/drawing/2014/main" id="{BB02CC8E-BA81-8C83-CCA0-DF2A0EC5171A}"/>
+              </a:ext>
+            </a:extLst>
+          </p:cNvPr>
+          <p:cNvGraphicFramePr>
+            <a:graphicFrameLocks noGrp="1"/>
+          </p:cNvGraphicFramePr>
+          <p:nvPr/>
+        </p:nvGraphicFramePr>
+        <p:xfrm>
+          <a:off x="7725213" y="1341438"/>
+          <a:ext cx="3193663" cy="1286652"/>
+        </p:xfrm>
+        <a:graphic>
+          <a:graphicData uri="http://schemas.openxmlformats.org/drawingml/2006/table">
+            <a:tbl>
+              <a:tblPr firstRow="1" bandRow="1">
+                <a:tableStyleId>{9D7B26C5-4107-4FEC-AEDC-1716B250A1EF}</a:tableStyleId>
+              </a:tblPr>
+              <a:tblGrid>
+                <a:gridCol w="1308506">
+                  <a:extLst>
+                    <a:ext uri="{9D8B030D-6E8A-4147-A177-3AD203B41FA5}">
+                      <a16:colId xmlns:a16="http://schemas.microsoft.com/office/drawing/2014/main" val="2029435156"/>
+                    </a:ext>
+                  </a:extLst>
+                </a:gridCol>
+                <a:gridCol w="1885157">
+                  <a:extLst>
+                    <a:ext uri="{9D8B030D-6E8A-4147-A177-3AD203B41FA5}">
+                      <a16:colId xmlns:a16="http://schemas.microsoft.com/office/drawing/2014/main" val="2594455307"/>
+                    </a:ext>
+                  </a:extLst>
+                </a:gridCol>
+              </a:tblGrid>
+              <a:tr h="321663">
+                <a:tc>
+                  <a:txBody>
+                    <a:bodyPr/>
+                    <a:lstStyle/>
+                    <a:p>
+                      <a:pPr algn="ctr"/>
+                      <a:r>
+                        <a:rPr lang="en-US" sz="1400" dirty="0"/>
+                        <a:t>Model</a:t>
+                      </a:r>
+                    </a:p>
+                  </a:txBody>
+                  <a:tcPr anchor="ctr">
+                    <a:lnL w="12700" cap="flat" cmpd="sng" algn="ctr">
+                      <a:solidFill>
+                        <a:schemeClr val="tx1"/>
+                      </a:solidFill>
+                      <a:prstDash val="solid"/>
+                      <a:round/>
+                      <a:headEnd type="none" w="med" len="med"/>
+                      <a:tailEnd type="none" w="med" len="med"/>
+                    </a:lnL>
+                    <a:lnT w="12700" cap="flat" cmpd="sng" algn="ctr">
+                      <a:solidFill>
+                        <a:schemeClr val="tx1"/>
+                      </a:solidFill>
+                      <a:prstDash val="solid"/>
+                      <a:round/>
+                      <a:headEnd type="none" w="med" len="med"/>
+                      <a:tailEnd type="none" w="med" len="med"/>
+                    </a:lnT>
+                  </a:tcPr>
+                </a:tc>
+                <a:tc>
+                  <a:txBody>
+                    <a:bodyPr/>
+                    <a:lstStyle/>
+                    <a:p>
+                      <a:pPr algn="ctr"/>
+                      <a:r>
+                        <a:rPr lang="en-US" sz="1400" dirty="0"/>
+                        <a:t>RMSE (m)</a:t>
+                      </a:r>
+                    </a:p>
+                  </a:txBody>
+                  <a:tcPr anchor="ctr">
+                    <a:lnR w="12700" cap="flat" cmpd="sng" algn="ctr">
+                      <a:solidFill>
+                        <a:schemeClr val="tx1"/>
+                      </a:solidFill>
+                      <a:prstDash val="solid"/>
+                      <a:round/>
+                      <a:headEnd type="none" w="med" len="med"/>
+                      <a:tailEnd type="none" w="med" len="med"/>
+                    </a:lnR>
+                    <a:lnT w="12700" cap="flat" cmpd="sng" algn="ctr">
+                      <a:solidFill>
+                        <a:schemeClr val="tx1"/>
+                      </a:solidFill>
+                      <a:prstDash val="solid"/>
+                      <a:round/>
+                      <a:headEnd type="none" w="med" len="med"/>
+                      <a:tailEnd type="none" w="med" len="med"/>
+                    </a:lnT>
+                  </a:tcPr>
+                </a:tc>
+                <a:extLst>
+                  <a:ext uri="{0D108BD9-81ED-4DB2-BD59-A6C34878D82A}">
+                    <a16:rowId xmlns:a16="http://schemas.microsoft.com/office/drawing/2014/main" val="1602097549"/>
+                  </a:ext>
+                </a:extLst>
+              </a:tr>
+              <a:tr h="321663">
+                <a:tc>
+                  <a:txBody>
+                    <a:bodyPr/>
+                    <a:lstStyle/>
+                    <a:p>
+                      <a:pPr algn="ctr"/>
+                      <a:r>
+                        <a:rPr lang="en-US" sz="1400" dirty="0"/>
+                        <a:t>SGP4</a:t>
+                      </a:r>
+                    </a:p>
+                  </a:txBody>
+                  <a:tcPr anchor="ctr">
+                    <a:lnL w="12700" cap="flat" cmpd="sng" algn="ctr">
+                      <a:solidFill>
+                        <a:schemeClr val="tx1"/>
+                      </a:solidFill>
+                      <a:prstDash val="solid"/>
+                      <a:round/>
+                      <a:headEnd type="none" w="med" len="med"/>
+                      <a:tailEnd type="none" w="med" len="med"/>
+                    </a:lnL>
+                  </a:tcPr>
+                </a:tc>
+                <a:tc>
+                  <a:txBody>
+                    <a:bodyPr/>
+                    <a:lstStyle/>
+                    <a:p>
+                      <a:pPr algn="ctr"/>
+                      <a:r>
+                        <a:rPr lang="en-US" sz="1400" dirty="0"/>
+                        <a:t>153.77</a:t>
+                      </a:r>
+                    </a:p>
+                  </a:txBody>
+                  <a:tcPr anchor="ctr">
+                    <a:lnR w="12700" cap="flat" cmpd="sng" algn="ctr">
+                      <a:solidFill>
+                        <a:schemeClr val="tx1"/>
+                      </a:solidFill>
+                      <a:prstDash val="solid"/>
+                      <a:round/>
+                      <a:headEnd type="none" w="med" len="med"/>
+                      <a:tailEnd type="none" w="med" len="med"/>
+                    </a:lnR>
+                  </a:tcPr>
+                </a:tc>
+                <a:extLst>
+                  <a:ext uri="{0D108BD9-81ED-4DB2-BD59-A6C34878D82A}">
+                    <a16:rowId xmlns:a16="http://schemas.microsoft.com/office/drawing/2014/main" val="1622130261"/>
+                  </a:ext>
+                </a:extLst>
+              </a:tr>
+              <a:tr h="321663">
+                <a:tc>
+                  <a:txBody>
+                    <a:bodyPr/>
+                    <a:lstStyle/>
+                    <a:p>
+                      <a:pPr algn="ctr"/>
+                      <a:r>
+                        <a:rPr lang="en-US" sz="1400" dirty="0"/>
+                        <a:t>TDNN</a:t>
+                      </a:r>
+                    </a:p>
+                  </a:txBody>
+                  <a:tcPr anchor="ctr">
+                    <a:lnL w="12700" cap="flat" cmpd="sng" algn="ctr">
+                      <a:solidFill>
+                        <a:schemeClr val="tx1"/>
+                      </a:solidFill>
+                      <a:prstDash val="solid"/>
+                      <a:round/>
+                      <a:headEnd type="none" w="med" len="med"/>
+                      <a:tailEnd type="none" w="med" len="med"/>
+                    </a:lnL>
+                  </a:tcPr>
+                </a:tc>
+                <a:tc>
+                  <a:txBody>
+                    <a:bodyPr/>
+                    <a:lstStyle/>
+                    <a:p>
+                      <a:pPr algn="ctr"/>
+                      <a:r>
+                        <a:rPr lang="en-US" sz="1400" dirty="0"/>
+                        <a:t>83.952</a:t>
+                      </a:r>
+                    </a:p>
+                  </a:txBody>
+                  <a:tcPr anchor="ctr">
+                    <a:lnR w="12700" cap="flat" cmpd="sng" algn="ctr">
+                      <a:solidFill>
+                        <a:schemeClr val="tx1"/>
+                      </a:solidFill>
+                      <a:prstDash val="solid"/>
+                      <a:round/>
+                      <a:headEnd type="none" w="med" len="med"/>
+                      <a:tailEnd type="none" w="med" len="med"/>
+                    </a:lnR>
+                  </a:tcPr>
+                </a:tc>
+                <a:extLst>
+                  <a:ext uri="{0D108BD9-81ED-4DB2-BD59-A6C34878D82A}">
+                    <a16:rowId xmlns:a16="http://schemas.microsoft.com/office/drawing/2014/main" val="2000138850"/>
+                  </a:ext>
+                </a:extLst>
+              </a:tr>
+              <a:tr h="321663">
+                <a:tc>
+                  <a:txBody>
+                    <a:bodyPr/>
+                    <a:lstStyle/>
+                    <a:p>
+                      <a:pPr algn="ctr"/>
+                      <a:r>
+                        <a:rPr lang="en-US" sz="1100" i="1" dirty="0"/>
+                        <a:t>Improvement</a:t>
+                      </a:r>
+                      <a:endParaRPr lang="en-US" sz="1400" i="1" dirty="0"/>
+                    </a:p>
+                  </a:txBody>
+                  <a:tcPr anchor="ctr">
+                    <a:lnL w="12700" cap="flat" cmpd="sng" algn="ctr">
+                      <a:solidFill>
+                        <a:schemeClr val="tx1"/>
+                      </a:solidFill>
+                      <a:prstDash val="solid"/>
+                      <a:round/>
+                      <a:headEnd type="none" w="med" len="med"/>
+                      <a:tailEnd type="none" w="med" len="med"/>
+                    </a:lnL>
+                  </a:tcPr>
+                </a:tc>
+                <a:tc>
+                  <a:txBody>
+                    <a:bodyPr/>
+                    <a:lstStyle/>
+                    <a:p>
+                      <a:pPr algn="ctr"/>
+                      <a:r>
+                        <a:rPr lang="en-US" sz="1400" dirty="0"/>
+                        <a:t>%45.40</a:t>
+                      </a:r>
+                    </a:p>
+                  </a:txBody>
+                  <a:tcPr anchor="ctr">
+                    <a:lnR w="12700" cap="flat" cmpd="sng" algn="ctr">
+                      <a:solidFill>
+                        <a:schemeClr val="tx1"/>
+                      </a:solidFill>
+                      <a:prstDash val="solid"/>
+                      <a:round/>
+                      <a:headEnd type="none" w="med" len="med"/>
+                      <a:tailEnd type="none" w="med" len="med"/>
+                    </a:lnR>
+                  </a:tcPr>
+                </a:tc>
+                <a:extLst>
+                  <a:ext uri="{0D108BD9-81ED-4DB2-BD59-A6C34878D82A}">
+                    <a16:rowId xmlns:a16="http://schemas.microsoft.com/office/drawing/2014/main" val="872423675"/>
+                  </a:ext>
+                </a:extLst>
+              </a:tr>
+            </a:tbl>
+          </a:graphicData>
+        </a:graphic>
+      </p:graphicFrame>
+      <p:sp>
+        <p:nvSpPr>
+          <p:cNvPr id="11" name="Text Placeholder 3">
+            <a:extLst>
+              <a:ext uri="{FF2B5EF4-FFF2-40B4-BE49-F238E27FC236}">
+                <a16:creationId xmlns:a16="http://schemas.microsoft.com/office/drawing/2014/main" id="{91D0784A-5CA7-FB00-6B7F-EAAA04C0AA00}"/>
+              </a:ext>
+            </a:extLst>
+          </p:cNvPr>
+          <p:cNvSpPr txBox="1">
+            <a:spLocks/>
+          </p:cNvSpPr>
+          <p:nvPr/>
+        </p:nvSpPr>
+        <p:spPr>
+          <a:xfrm>
+            <a:off x="135539" y="4533900"/>
+            <a:ext cx="6693886" cy="2210547"/>
+          </a:xfrm>
+          <a:prstGeom prst="rect">
+            <a:avLst/>
+          </a:prstGeom>
+        </p:spPr>
+        <p:txBody>
+          <a:bodyPr vert="horz" lIns="91440" tIns="45720" rIns="91440" bIns="45720" rtlCol="0">
+            <a:normAutofit/>
+          </a:bodyPr>
+          <a:lstStyle>
+            <a:lvl1pPr marL="342900" indent="-342900" defTabSz="457200">
+              <a:spcBef>
+                <a:spcPts val="700"/>
+              </a:spcBef>
+              <a:buClr>
+                <a:srgbClr val="000000"/>
+              </a:buClr>
+              <a:buSzPct val="100000"/>
+              <a:buFont typeface="Arial"/>
+              <a:buChar char="•"/>
+              <a:defRPr sz="2800">
+                <a:solidFill>
+                  <a:srgbClr val="03244D"/>
+                </a:solidFill>
+                <a:uFill>
+                  <a:solidFill/>
+                </a:uFill>
+                <a:latin typeface="+mn-lt"/>
+                <a:ea typeface="+mn-ea"/>
+                <a:cs typeface="Arial" panose="020B0604020202020204" pitchFamily="34" charset="0"/>
+                <a:sym typeface="Calibri"/>
+              </a:defRPr>
+            </a:lvl1pPr>
+            <a:lvl2pPr marL="783771" indent="-326571" defTabSz="457200">
+              <a:spcBef>
+                <a:spcPts val="700"/>
+              </a:spcBef>
+              <a:buClr>
+                <a:srgbClr val="000000"/>
+              </a:buClr>
+              <a:buSzPct val="100000"/>
+              <a:buFont typeface="Arial"/>
+              <a:buChar char="•"/>
+              <a:defRPr sz="2400">
+                <a:solidFill>
+                  <a:srgbClr val="03244D"/>
+                </a:solidFill>
+                <a:uFill>
+                  <a:solidFill/>
+                </a:uFill>
+                <a:latin typeface="+mn-lt"/>
+                <a:ea typeface="+mn-ea"/>
+                <a:cs typeface="Arial" panose="020B0604020202020204" pitchFamily="34" charset="0"/>
+                <a:sym typeface="Calibri"/>
+              </a:defRPr>
+            </a:lvl2pPr>
+            <a:lvl3pPr marL="1219200" indent="-304800" defTabSz="457200">
+              <a:spcBef>
+                <a:spcPts val="700"/>
+              </a:spcBef>
+              <a:buClr>
+                <a:srgbClr val="000000"/>
+              </a:buClr>
+              <a:buSzPct val="100000"/>
+              <a:buFont typeface="Arial"/>
+              <a:buChar char="•"/>
+              <a:defRPr sz="2000">
+                <a:solidFill>
+                  <a:srgbClr val="03244D"/>
+                </a:solidFill>
+                <a:uFill>
+                  <a:solidFill/>
+                </a:uFill>
+                <a:latin typeface="+mn-lt"/>
+                <a:ea typeface="+mn-ea"/>
+                <a:cs typeface="Arial" panose="020B0604020202020204" pitchFamily="34" charset="0"/>
+                <a:sym typeface="Calibri"/>
+              </a:defRPr>
+            </a:lvl3pPr>
+            <a:lvl4pPr marL="1737360" indent="-365760" defTabSz="457200">
+              <a:spcBef>
+                <a:spcPts val="700"/>
+              </a:spcBef>
+              <a:buClr>
+                <a:srgbClr val="000000"/>
+              </a:buClr>
+              <a:buSzPct val="100000"/>
+              <a:buFont typeface="Arial"/>
+              <a:buChar char="•"/>
+              <a:defRPr sz="2000">
+                <a:solidFill>
+                  <a:srgbClr val="03244D"/>
+                </a:solidFill>
+                <a:uFill>
+                  <a:solidFill/>
+                </a:uFill>
+                <a:latin typeface="+mn-lt"/>
+                <a:ea typeface="+mn-ea"/>
+                <a:cs typeface="Arial" panose="020B0604020202020204" pitchFamily="34" charset="0"/>
+                <a:sym typeface="Calibri"/>
+              </a:defRPr>
+            </a:lvl4pPr>
+            <a:lvl5pPr marL="2194560" indent="-365760" defTabSz="457200">
+              <a:spcBef>
+                <a:spcPts val="700"/>
+              </a:spcBef>
+              <a:buClr>
+                <a:srgbClr val="000000"/>
+              </a:buClr>
+              <a:buSzPct val="100000"/>
+              <a:buFont typeface="Arial"/>
+              <a:buChar char="•"/>
+              <a:defRPr sz="2000">
+                <a:solidFill>
+                  <a:srgbClr val="03244D"/>
+                </a:solidFill>
+                <a:uFill>
+                  <a:solidFill/>
+                </a:uFill>
+                <a:latin typeface="+mn-lt"/>
+                <a:ea typeface="+mn-ea"/>
+                <a:cs typeface="Arial" panose="020B0604020202020204" pitchFamily="34" charset="0"/>
+                <a:sym typeface="Calibri"/>
+              </a:defRPr>
+            </a:lvl5pPr>
+            <a:lvl6pPr marL="2451100" indent="0" defTabSz="457200">
+              <a:spcBef>
+                <a:spcPts val="700"/>
+              </a:spcBef>
+              <a:buClr>
+                <a:srgbClr val="000000"/>
+              </a:buClr>
+              <a:buSzPct val="171000"/>
+              <a:buFont typeface="Arial"/>
+              <a:buNone/>
+              <a:defRPr sz="1800">
+                <a:solidFill>
+                  <a:srgbClr val="03244D"/>
+                </a:solidFill>
+                <a:uFill>
+                  <a:solidFill/>
+                </a:uFill>
+                <a:latin typeface="Arial" panose="020B0604020202020204" pitchFamily="34" charset="0"/>
+                <a:ea typeface="+mn-ea"/>
+                <a:cs typeface="Arial" panose="020B0604020202020204" pitchFamily="34" charset="0"/>
+                <a:sym typeface="Calibri"/>
+              </a:defRPr>
+            </a:lvl6pPr>
+            <a:lvl7pPr marL="3721100" indent="-914400" defTabSz="457200">
+              <a:spcBef>
+                <a:spcPts val="700"/>
+              </a:spcBef>
+              <a:buClr>
+                <a:srgbClr val="000000"/>
+              </a:buClr>
+              <a:buSzPct val="171000"/>
+              <a:buFont typeface="Arial"/>
+              <a:buChar char="•"/>
+              <a:defRPr sz="3200">
+                <a:uFill>
+                  <a:solidFill/>
+                </a:uFill>
+                <a:latin typeface="+mn-lt"/>
+                <a:ea typeface="+mn-ea"/>
+                <a:cs typeface="+mn-cs"/>
+                <a:sym typeface="Calibri"/>
+              </a:defRPr>
+            </a:lvl7pPr>
+            <a:lvl8pPr marL="4076700" indent="-914400" defTabSz="457200">
+              <a:spcBef>
+                <a:spcPts val="700"/>
+              </a:spcBef>
+              <a:buClr>
+                <a:srgbClr val="000000"/>
+              </a:buClr>
+              <a:buSzPct val="171000"/>
+              <a:buFont typeface="Arial"/>
+              <a:buChar char="•"/>
+              <a:defRPr sz="3200">
+                <a:uFill>
+                  <a:solidFill/>
+                </a:uFill>
+                <a:latin typeface="+mn-lt"/>
+                <a:ea typeface="+mn-ea"/>
+                <a:cs typeface="+mn-cs"/>
+                <a:sym typeface="Calibri"/>
+              </a:defRPr>
+            </a:lvl8pPr>
+            <a:lvl9pPr marL="4432300" indent="-914400" defTabSz="457200">
+              <a:spcBef>
+                <a:spcPts val="700"/>
+              </a:spcBef>
+              <a:buClr>
+                <a:srgbClr val="000000"/>
+              </a:buClr>
+              <a:buSzPct val="171000"/>
+              <a:buFont typeface="Arial"/>
+              <a:buChar char="•"/>
+              <a:defRPr sz="3200">
+                <a:uFill>
+                  <a:solidFill/>
+                </a:uFill>
+                <a:latin typeface="+mn-lt"/>
+                <a:ea typeface="+mn-ea"/>
+                <a:cs typeface="+mn-cs"/>
+                <a:sym typeface="Calibri"/>
+              </a:defRPr>
+            </a:lvl9pPr>
+          </a:lstStyle>
+          <a:p>
+            <a:r>
+              <a:rPr lang="en-US" dirty="0"/>
+              <a:t>While the mean error is decreased, there appears to be a bias is the estimate. </a:t>
+            </a:r>
           </a:p>
         </p:txBody>
       </p:sp>
@@ -2871,7 +3452,7 @@
 </p:sld>
 </file>
 
-<file path=ppt/slides/slide12.xml><?xml version="1.0" encoding="utf-8"?>
+<file path=ppt/slides/slide11.xml><?xml version="1.0" encoding="utf-8"?>
 <p:sld xmlns:a="http://schemas.openxmlformats.org/drawingml/2006/main" xmlns:r="http://schemas.openxmlformats.org/officeDocument/2006/relationships" xmlns:p="http://schemas.openxmlformats.org/presentationml/2006/main">
   <p:cSld>
     <p:spTree>
@@ -2946,7 +3527,7 @@
             <a:fld id="{CAC3FE34-2808-40E6-BEA2-B7CA77D47CA5}" type="slidenum">
               <a:rPr lang="en-US" smtClean="0"/>
               <a:pPr/>
-              <a:t>12</a:t>
+              <a:t>11</a:t>
             </a:fld>
             <a:endParaRPr lang="en-US" dirty="0"/>
           </a:p>
@@ -2973,7 +3554,28 @@
           <a:bodyPr/>
           <a:lstStyle/>
           <a:p>
-            <a:endParaRPr lang="en-US"/>
+            <a:r>
+              <a:rPr lang="en-US" dirty="0"/>
+              <a:t>The TDNN showed viable performance to improve satellite propagation</a:t>
+            </a:r>
+          </a:p>
+          <a:p>
+            <a:r>
+              <a:rPr lang="en-US" dirty="0"/>
+              <a:t>Evaluating the TDNN within a positioning algorithm to fully quantify the improvements of the model</a:t>
+            </a:r>
+          </a:p>
+          <a:p>
+            <a:r>
+              <a:rPr lang="en-US" dirty="0"/>
+              <a:t>Expanding this model to estimate satellite positions for commercial satellites, rather than a scientific satellite.</a:t>
+            </a:r>
+          </a:p>
+          <a:p>
+            <a:r>
+              <a:rPr lang="en-US" dirty="0"/>
+              <a:t> An exploratory study on changing number and size of Conv1D and dense layers would prove benefit to evaluating the TDNN</a:t>
+            </a:r>
           </a:p>
         </p:txBody>
       </p:sp>
@@ -2981,6 +3583,175 @@
     <p:extLst>
       <p:ext uri="{BB962C8B-B14F-4D97-AF65-F5344CB8AC3E}">
         <p14:creationId xmlns:p14="http://schemas.microsoft.com/office/powerpoint/2010/main" val="2792655864"/>
+      </p:ext>
+    </p:extLst>
+  </p:cSld>
+  <p:clrMapOvr>
+    <a:masterClrMapping/>
+  </p:clrMapOvr>
+  <p:transition spd="med"/>
+</p:sld>
+</file>
+
+<file path=ppt/slides/slide12.xml><?xml version="1.0" encoding="utf-8"?>
+<p:sld xmlns:a="http://schemas.openxmlformats.org/drawingml/2006/main" xmlns:r="http://schemas.openxmlformats.org/officeDocument/2006/relationships" xmlns:p="http://schemas.openxmlformats.org/presentationml/2006/main">
+  <p:cSld>
+    <p:spTree>
+      <p:nvGrpSpPr>
+        <p:cNvPr id="1" name="">
+          <a:extLst>
+            <a:ext uri="{FF2B5EF4-FFF2-40B4-BE49-F238E27FC236}">
+              <a16:creationId xmlns:a16="http://schemas.microsoft.com/office/drawing/2014/main" id="{A09EE6ED-DB89-ABEE-3DE2-544FC0732CF1}"/>
+            </a:ext>
+          </a:extLst>
+        </p:cNvPr>
+        <p:cNvGrpSpPr/>
+        <p:nvPr/>
+      </p:nvGrpSpPr>
+      <p:grpSpPr>
+        <a:xfrm>
+          <a:off x="0" y="0"/>
+          <a:ext cx="0" cy="0"/>
+          <a:chOff x="0" y="0"/>
+          <a:chExt cx="0" cy="0"/>
+        </a:xfrm>
+      </p:grpSpPr>
+      <p:sp>
+        <p:nvSpPr>
+          <p:cNvPr id="2" name="Title 1">
+            <a:extLst>
+              <a:ext uri="{FF2B5EF4-FFF2-40B4-BE49-F238E27FC236}">
+                <a16:creationId xmlns:a16="http://schemas.microsoft.com/office/drawing/2014/main" id="{9D435C50-FF45-578F-4A4F-F12C2E2D6BD8}"/>
+              </a:ext>
+            </a:extLst>
+          </p:cNvPr>
+          <p:cNvSpPr>
+            <a:spLocks noGrp="1"/>
+          </p:cNvSpPr>
+          <p:nvPr>
+            <p:ph type="title"/>
+          </p:nvPr>
+        </p:nvSpPr>
+        <p:spPr/>
+        <p:txBody>
+          <a:bodyPr/>
+          <a:lstStyle/>
+          <a:p>
+            <a:r>
+              <a:rPr lang="en-US" dirty="0"/>
+              <a:t>References</a:t>
+            </a:r>
+          </a:p>
+        </p:txBody>
+      </p:sp>
+      <p:sp>
+        <p:nvSpPr>
+          <p:cNvPr id="3" name="Slide Number Placeholder 2">
+            <a:extLst>
+              <a:ext uri="{FF2B5EF4-FFF2-40B4-BE49-F238E27FC236}">
+                <a16:creationId xmlns:a16="http://schemas.microsoft.com/office/drawing/2014/main" id="{D7619E7D-4186-3F4C-61D6-03D4ABB01B50}"/>
+              </a:ext>
+            </a:extLst>
+          </p:cNvPr>
+          <p:cNvSpPr>
+            <a:spLocks noGrp="1"/>
+          </p:cNvSpPr>
+          <p:nvPr>
+            <p:ph type="sldNum" sz="quarter" idx="10"/>
+          </p:nvPr>
+        </p:nvSpPr>
+        <p:spPr/>
+        <p:txBody>
+          <a:bodyPr/>
+          <a:lstStyle/>
+          <a:p>
+            <a:fld id="{CAC3FE34-2808-40E6-BEA2-B7CA77D47CA5}" type="slidenum">
+              <a:rPr lang="en-US" smtClean="0"/>
+              <a:pPr/>
+              <a:t>12</a:t>
+            </a:fld>
+            <a:endParaRPr lang="en-US" dirty="0"/>
+          </a:p>
+        </p:txBody>
+      </p:sp>
+      <p:sp>
+        <p:nvSpPr>
+          <p:cNvPr id="4" name="Text Placeholder 3">
+            <a:extLst>
+              <a:ext uri="{FF2B5EF4-FFF2-40B4-BE49-F238E27FC236}">
+                <a16:creationId xmlns:a16="http://schemas.microsoft.com/office/drawing/2014/main" id="{264643EC-9C33-BC06-6698-783CA1B70136}"/>
+              </a:ext>
+            </a:extLst>
+          </p:cNvPr>
+          <p:cNvSpPr>
+            <a:spLocks noGrp="1"/>
+          </p:cNvSpPr>
+          <p:nvPr>
+            <p:ph type="body" sz="quarter" idx="11"/>
+          </p:nvPr>
+        </p:nvSpPr>
+        <p:spPr/>
+        <p:txBody>
+          <a:bodyPr/>
+          <a:lstStyle/>
+          <a:p>
+            <a:r>
+              <a:rPr lang="en-US" dirty="0"/>
+              <a:t>[1] Sharbel </a:t>
+            </a:r>
+            <a:r>
+              <a:rPr lang="en-US" dirty="0" err="1"/>
+              <a:t>Kozhaya</a:t>
+            </a:r>
+            <a:r>
+              <a:rPr lang="en-US" dirty="0"/>
+              <a:t>, Jamil Haidar-Ahmad, Ali Abdallah, </a:t>
+            </a:r>
+            <a:r>
+              <a:rPr lang="en-US" dirty="0" err="1"/>
+              <a:t>ZaherKassas</a:t>
+            </a:r>
+            <a:r>
+              <a:rPr lang="en-US" dirty="0"/>
+              <a:t>, and Samer Saab. Comparison of neural network </a:t>
+            </a:r>
+            <a:r>
+              <a:rPr lang="en-US" dirty="0" err="1"/>
+              <a:t>archi-tectures</a:t>
+            </a:r>
+            <a:r>
+              <a:rPr lang="en-US" dirty="0"/>
+              <a:t> for simultaneous tracking and navigation with </a:t>
+            </a:r>
+            <a:r>
+              <a:rPr lang="en-US" dirty="0" err="1"/>
+              <a:t>LEOsatellites</a:t>
+            </a:r>
+            <a:r>
+              <a:rPr lang="en-US" dirty="0"/>
+              <a:t>. In Proceedings of the ION GNSS+ </a:t>
+            </a:r>
+            <a:r>
+              <a:rPr lang="en-US" dirty="0" err="1"/>
+              <a:t>Conference,pages</a:t>
+            </a:r>
+            <a:r>
+              <a:rPr lang="en-US" dirty="0"/>
+              <a:t> 1–10, St. Louis, MO, 2021</a:t>
+            </a:r>
+          </a:p>
+          <a:p>
+            <a:r>
+              <a:rPr lang="en-US" dirty="0"/>
+              <a:t>[2]</a:t>
+            </a:r>
+          </a:p>
+        </p:txBody>
+      </p:sp>
+    </p:spTree>
+    <p:extLst>
+      <p:ext uri="{BB962C8B-B14F-4D97-AF65-F5344CB8AC3E}">
+        <p14:creationId xmlns:p14="http://schemas.microsoft.com/office/powerpoint/2010/main" val="1941086294"/>
       </p:ext>
     </p:extLst>
   </p:cSld>
@@ -3171,7 +3942,7 @@
         <p:cNvPr id="1" name="">
           <a:extLst>
             <a:ext uri="{FF2B5EF4-FFF2-40B4-BE49-F238E27FC236}">
-              <a16:creationId xmlns:a16="http://schemas.microsoft.com/office/drawing/2014/main" id="{EF58742D-222B-D594-E389-B18F743EB896}"/>
+              <a16:creationId xmlns:a16="http://schemas.microsoft.com/office/drawing/2014/main" id="{3ACF5CEB-8FAE-3BC2-96EA-A89F42BC9BE3}"/>
             </a:ext>
           </a:extLst>
         </p:cNvPr>
@@ -3188,145 +3959,92 @@
       </p:grpSpPr>
       <p:sp>
         <p:nvSpPr>
-          <p:cNvPr id="2" name="Title 1">
+          <p:cNvPr id="6" name="Rectangle 5">
             <a:extLst>
               <a:ext uri="{FF2B5EF4-FFF2-40B4-BE49-F238E27FC236}">
-                <a16:creationId xmlns:a16="http://schemas.microsoft.com/office/drawing/2014/main" id="{8C86E644-E6D6-8C1C-3993-88552DE3CF95}"/>
+                <a16:creationId xmlns:a16="http://schemas.microsoft.com/office/drawing/2014/main" id="{7EFECE14-EE9D-F5A7-E60A-FA8B414F4988}"/>
               </a:ext>
             </a:extLst>
           </p:cNvPr>
-          <p:cNvSpPr>
-            <a:spLocks noGrp="1"/>
-          </p:cNvSpPr>
-          <p:nvPr>
-            <p:ph type="title"/>
-          </p:nvPr>
+          <p:cNvSpPr/>
+          <p:nvPr/>
         </p:nvSpPr>
-        <p:spPr/>
+        <p:spPr>
+          <a:xfrm>
+            <a:off x="10542202" y="5412565"/>
+            <a:ext cx="1552575" cy="1390650"/>
+          </a:xfrm>
+          <a:prstGeom prst="rect">
+            <a:avLst/>
+          </a:prstGeom>
+          <a:solidFill>
+            <a:schemeClr val="bg1"/>
+          </a:solidFill>
+          <a:ln w="12700" cap="flat">
+            <a:noFill/>
+            <a:miter lim="400000"/>
+          </a:ln>
+          <a:effectLst/>
+        </p:spPr>
+        <p:style>
+          <a:lnRef idx="0">
+            <a:scrgbClr r="0" g="0" b="0"/>
+          </a:lnRef>
+          <a:fillRef idx="0">
+            <a:scrgbClr r="0" g="0" b="0"/>
+          </a:fillRef>
+          <a:effectRef idx="0">
+            <a:scrgbClr r="0" g="0" b="0"/>
+          </a:effectRef>
+          <a:fontRef idx="none"/>
+        </p:style>
         <p:txBody>
-          <a:bodyPr/>
+          <a:bodyPr rot="0" spcFirstLastPara="1" vertOverflow="overflow" horzOverflow="overflow" vert="horz" wrap="square" lIns="50800" tIns="50800" rIns="50800" bIns="50800" numCol="1" spcCol="38100" rtlCol="0" anchor="ctr">
+            <a:spAutoFit/>
+          </a:bodyPr>
           <a:lstStyle/>
           <a:p>
-            <a:r>
-              <a:rPr lang="en-US" dirty="0"/>
-              <a:t>LEO Satellite Qualities </a:t>
-            </a:r>
+            <a:pPr marL="0" marR="0" indent="0" algn="ctr" defTabSz="584200" rtl="0" fontAlgn="auto" latinLnBrk="1" hangingPunct="0">
+              <a:lnSpc>
+                <a:spcPct val="100000"/>
+              </a:lnSpc>
+              <a:spcBef>
+                <a:spcPts val="0"/>
+              </a:spcBef>
+              <a:spcAft>
+                <a:spcPts val="0"/>
+              </a:spcAft>
+              <a:buClr>
+                <a:srgbClr val="000000"/>
+              </a:buClr>
+              <a:buSzTx/>
+              <a:buFont typeface="Calibri"/>
+              <a:buNone/>
+              <a:tabLst/>
+            </a:pPr>
+            <a:endParaRPr kumimoji="0" lang="en-US" sz="4000" b="0" i="0" u="none" strike="noStrike" cap="none" spc="0" normalizeH="0" baseline="0">
+              <a:ln>
+                <a:noFill/>
+              </a:ln>
+              <a:solidFill>
+                <a:srgbClr val="FFFFFF"/>
+              </a:solidFill>
+              <a:effectLst>
+                <a:outerShdw blurRad="38100" dist="12700" dir="5400000" rotWithShape="0">
+                  <a:srgbClr val="000000">
+                    <a:alpha val="50000"/>
+                  </a:srgbClr>
+                </a:outerShdw>
+              </a:effectLst>
+              <a:uFillTx/>
+              <a:latin typeface="+mn-lt"/>
+              <a:ea typeface="+mn-ea"/>
+              <a:cs typeface="+mn-cs"/>
+              <a:sym typeface="Calibri"/>
+            </a:endParaRPr>
           </a:p>
         </p:txBody>
       </p:sp>
-      <p:sp>
-        <p:nvSpPr>
-          <p:cNvPr id="3" name="Slide Number Placeholder 2">
-            <a:extLst>
-              <a:ext uri="{FF2B5EF4-FFF2-40B4-BE49-F238E27FC236}">
-                <a16:creationId xmlns:a16="http://schemas.microsoft.com/office/drawing/2014/main" id="{0ADB3112-994C-8998-CDD8-E4A72CDEA033}"/>
-              </a:ext>
-            </a:extLst>
-          </p:cNvPr>
-          <p:cNvSpPr>
-            <a:spLocks noGrp="1"/>
-          </p:cNvSpPr>
-          <p:nvPr>
-            <p:ph type="sldNum" sz="quarter" idx="10"/>
-          </p:nvPr>
-        </p:nvSpPr>
-        <p:spPr/>
-        <p:txBody>
-          <a:bodyPr/>
-          <a:lstStyle/>
-          <a:p>
-            <a:fld id="{CAC3FE34-2808-40E6-BEA2-B7CA77D47CA5}" type="slidenum">
-              <a:rPr lang="en-US" smtClean="0"/>
-              <a:pPr/>
-              <a:t>3</a:t>
-            </a:fld>
-            <a:endParaRPr lang="en-US" dirty="0"/>
-          </a:p>
-        </p:txBody>
-      </p:sp>
-      <p:sp>
-        <p:nvSpPr>
-          <p:cNvPr id="4" name="Text Placeholder 3">
-            <a:extLst>
-              <a:ext uri="{FF2B5EF4-FFF2-40B4-BE49-F238E27FC236}">
-                <a16:creationId xmlns:a16="http://schemas.microsoft.com/office/drawing/2014/main" id="{864BC29A-F8C2-6E4F-8302-96A018325FF2}"/>
-              </a:ext>
-            </a:extLst>
-          </p:cNvPr>
-          <p:cNvSpPr>
-            <a:spLocks noGrp="1"/>
-          </p:cNvSpPr>
-          <p:nvPr>
-            <p:ph type="body" sz="quarter" idx="11"/>
-          </p:nvPr>
-        </p:nvSpPr>
-        <p:spPr/>
-        <p:txBody>
-          <a:bodyPr/>
-          <a:lstStyle/>
-          <a:p>
-            <a:r>
-              <a:rPr lang="en-US" dirty="0"/>
-              <a:t>Typical Global Navigation Satellite Systems (GNSS) broadcast a signal with a modulated pseudorandom code that allows the user to “find” the signal below the noise floor</a:t>
-            </a:r>
-          </a:p>
-          <a:p>
-            <a:r>
-              <a:rPr lang="en-US" dirty="0"/>
-              <a:t>In contrast, many LEO satellites can be directly signal processed due to his high received signal power</a:t>
-            </a:r>
-          </a:p>
-          <a:p>
-            <a:r>
-              <a:rPr lang="en-US" dirty="0"/>
-              <a:t>This allows the signal to penetrate indoors and becomes easier for a receiver to maintain signal tracking</a:t>
-            </a:r>
-          </a:p>
-          <a:p>
-            <a:r>
-              <a:rPr lang="en-US" dirty="0"/>
-              <a:t>With the explosion </a:t>
-            </a:r>
-          </a:p>
-        </p:txBody>
-      </p:sp>
-    </p:spTree>
-    <p:extLst>
-      <p:ext uri="{BB962C8B-B14F-4D97-AF65-F5344CB8AC3E}">
-        <p14:creationId xmlns:p14="http://schemas.microsoft.com/office/powerpoint/2010/main" val="203478348"/>
-      </p:ext>
-    </p:extLst>
-  </p:cSld>
-  <p:clrMapOvr>
-    <a:masterClrMapping/>
-  </p:clrMapOvr>
-  <p:transition spd="med"/>
-</p:sld>
-</file>
-
-<file path=ppt/slides/slide4.xml><?xml version="1.0" encoding="utf-8"?>
-<p:sld xmlns:a="http://schemas.openxmlformats.org/drawingml/2006/main" xmlns:r="http://schemas.openxmlformats.org/officeDocument/2006/relationships" xmlns:p="http://schemas.openxmlformats.org/presentationml/2006/main">
-  <p:cSld>
-    <p:spTree>
-      <p:nvGrpSpPr>
-        <p:cNvPr id="1" name="">
-          <a:extLst>
-            <a:ext uri="{FF2B5EF4-FFF2-40B4-BE49-F238E27FC236}">
-              <a16:creationId xmlns:a16="http://schemas.microsoft.com/office/drawing/2014/main" id="{3ACF5CEB-8FAE-3BC2-96EA-A89F42BC9BE3}"/>
-            </a:ext>
-          </a:extLst>
-        </p:cNvPr>
-        <p:cNvGrpSpPr/>
-        <p:nvPr/>
-      </p:nvGrpSpPr>
-      <p:grpSpPr>
-        <a:xfrm>
-          <a:off x="0" y="0"/>
-          <a:ext cx="0" cy="0"/>
-          <a:chOff x="0" y="0"/>
-          <a:chExt cx="0" cy="0"/>
-        </a:xfrm>
-      </p:grpSpPr>
       <p:sp>
         <p:nvSpPr>
           <p:cNvPr id="2" name="Title 1">
@@ -3379,7 +4097,7 @@
             <a:fld id="{CAC3FE34-2808-40E6-BEA2-B7CA77D47CA5}" type="slidenum">
               <a:rPr lang="en-US" smtClean="0"/>
               <a:pPr/>
-              <a:t>4</a:t>
+              <a:t>3</a:t>
             </a:fld>
             <a:endParaRPr lang="en-US" dirty="0"/>
           </a:p>
@@ -3438,6 +4156,36 @@
           </a:p>
         </p:txBody>
       </p:sp>
+      <p:pic>
+        <p:nvPicPr>
+          <p:cNvPr id="5" name="Picture 4">
+            <a:extLst>
+              <a:ext uri="{FF2B5EF4-FFF2-40B4-BE49-F238E27FC236}">
+                <a16:creationId xmlns:a16="http://schemas.microsoft.com/office/drawing/2014/main" id="{F7EC35C2-08EA-5E54-52E9-71A7557D30CD}"/>
+              </a:ext>
+            </a:extLst>
+          </p:cNvPr>
+          <p:cNvPicPr>
+            <a:picLocks noChangeAspect="1"/>
+          </p:cNvPicPr>
+          <p:nvPr/>
+        </p:nvPicPr>
+        <p:blipFill>
+          <a:blip r:embed="rId2"/>
+          <a:stretch>
+            <a:fillRect/>
+          </a:stretch>
+        </p:blipFill>
+        <p:spPr>
+          <a:xfrm>
+            <a:off x="7595232" y="1390936"/>
+            <a:ext cx="4461228" cy="5362780"/>
+          </a:xfrm>
+          <a:prstGeom prst="rect">
+            <a:avLst/>
+          </a:prstGeom>
+        </p:spPr>
+      </p:pic>
     </p:spTree>
     <p:extLst>
       <p:ext uri="{BB962C8B-B14F-4D97-AF65-F5344CB8AC3E}">
@@ -3452,7 +4200,7 @@
 </p:sld>
 </file>
 
-<file path=ppt/slides/slide5.xml><?xml version="1.0" encoding="utf-8"?>
+<file path=ppt/slides/slide4.xml><?xml version="1.0" encoding="utf-8"?>
 <p:sld xmlns:a="http://schemas.openxmlformats.org/drawingml/2006/main" xmlns:r="http://schemas.openxmlformats.org/officeDocument/2006/relationships" xmlns:p="http://schemas.openxmlformats.org/presentationml/2006/main">
   <p:cSld>
     <p:spTree>
@@ -3527,14 +4275,14 @@
             <a:fld id="{CAC3FE34-2808-40E6-BEA2-B7CA77D47CA5}" type="slidenum">
               <a:rPr lang="en-US" smtClean="0"/>
               <a:pPr/>
-              <a:t>5</a:t>
+              <a:t>4</a:t>
             </a:fld>
             <a:endParaRPr lang="en-US" dirty="0"/>
           </a:p>
         </p:txBody>
       </p:sp>
-      <mc:AlternateContent xmlns:mc="http://schemas.openxmlformats.org/markup-compatibility/2006">
-        <mc:Choice xmlns:a14="http://schemas.microsoft.com/office/drawing/2010/main" Requires="a14">
+      <mc:AlternateContent xmlns:mc="http://schemas.openxmlformats.org/markup-compatibility/2006" xmlns:a14="http://schemas.microsoft.com/office/drawing/2010/main">
+        <mc:Choice Requires="a14">
           <p:sp>
             <p:nvSpPr>
               <p:cNvPr id="4" name="Text Placeholder 3">
@@ -3648,7 +4396,7 @@
             </p:txBody>
           </p:sp>
         </mc:Choice>
-        <mc:Fallback>
+        <mc:Fallback xmlns="">
           <p:sp>
             <p:nvSpPr>
               <p:cNvPr id="4" name="Text Placeholder 3">
@@ -4242,7 +4990,7 @@
 </p:sld>
 </file>
 
-<file path=ppt/slides/slide6.xml><?xml version="1.0" encoding="utf-8"?>
+<file path=ppt/slides/slide5.xml><?xml version="1.0" encoding="utf-8"?>
 <p:sld xmlns:a="http://schemas.openxmlformats.org/drawingml/2006/main" xmlns:r="http://schemas.openxmlformats.org/officeDocument/2006/relationships" xmlns:p="http://schemas.openxmlformats.org/presentationml/2006/main">
   <p:cSld>
     <p:spTree>
@@ -4317,7 +5065,7 @@
             <a:fld id="{CAC3FE34-2808-40E6-BEA2-B7CA77D47CA5}" type="slidenum">
               <a:rPr lang="en-US" smtClean="0"/>
               <a:pPr/>
-              <a:t>6</a:t>
+              <a:t>5</a:t>
             </a:fld>
             <a:endParaRPr lang="en-US" dirty="0"/>
           </a:p>
@@ -4353,7 +5101,7 @@
           <a:p>
             <a:r>
               <a:rPr lang="en-US" dirty="0"/>
-              <a:t>This project attempts to create a Time Dependent Neural Network (TDNN) to estimate a satellites position using both pseudo-published ephemeris and published TLEs</a:t>
+              <a:t>This project attempts to create a Time Dependent Neural Network (TDNN) to estimate a satellites position using both pseudo-published ephemeris and published TLEs [1], [</a:t>
             </a:r>
           </a:p>
           <a:p>
@@ -4414,7 +5162,7 @@
 </p:sld>
 </file>
 
-<file path=ppt/slides/slide7.xml><?xml version="1.0" encoding="utf-8"?>
+<file path=ppt/slides/slide6.xml><?xml version="1.0" encoding="utf-8"?>
 <p:sld xmlns:a="http://schemas.openxmlformats.org/drawingml/2006/main" xmlns:r="http://schemas.openxmlformats.org/officeDocument/2006/relationships" xmlns:p="http://schemas.openxmlformats.org/presentationml/2006/main">
   <p:cSld>
     <p:spTree>
@@ -4489,7 +5237,7 @@
             <a:fld id="{CAC3FE34-2808-40E6-BEA2-B7CA77D47CA5}" type="slidenum">
               <a:rPr lang="en-US" smtClean="0"/>
               <a:pPr/>
-              <a:t>7</a:t>
+              <a:t>6</a:t>
             </a:fld>
             <a:endParaRPr lang="en-US" dirty="0"/>
           </a:p>
@@ -4579,7 +5327,7 @@
         </p:blipFill>
         <p:spPr>
           <a:xfrm>
-            <a:off x="2192482" y="3220893"/>
+            <a:off x="2415886" y="3185102"/>
             <a:ext cx="7360227" cy="3672898"/>
           </a:xfrm>
           <a:prstGeom prst="rect">
@@ -4601,7 +5349,7 @@
 </p:sld>
 </file>
 
-<file path=ppt/slides/slide8.xml><?xml version="1.0" encoding="utf-8"?>
+<file path=ppt/slides/slide7.xml><?xml version="1.0" encoding="utf-8"?>
 <p:sld xmlns:a="http://schemas.openxmlformats.org/drawingml/2006/main" xmlns:r="http://schemas.openxmlformats.org/officeDocument/2006/relationships" xmlns:p="http://schemas.openxmlformats.org/presentationml/2006/main">
   <p:cSld>
     <p:spTree>
@@ -4609,7 +5357,7 @@
         <p:cNvPr id="1" name="">
           <a:extLst>
             <a:ext uri="{FF2B5EF4-FFF2-40B4-BE49-F238E27FC236}">
-              <a16:creationId xmlns:a16="http://schemas.microsoft.com/office/drawing/2014/main" id="{173BB17E-002B-4F6C-6BB7-B49646CD16E4}"/>
+              <a16:creationId xmlns:a16="http://schemas.microsoft.com/office/drawing/2014/main" id="{EF8F290D-F87E-1EE5-6427-C03B465B6A63}"/>
             </a:ext>
           </a:extLst>
         </p:cNvPr>
@@ -4629,7 +5377,7 @@
           <p:cNvPr id="2" name="Title 1">
             <a:extLst>
               <a:ext uri="{FF2B5EF4-FFF2-40B4-BE49-F238E27FC236}">
-                <a16:creationId xmlns:a16="http://schemas.microsoft.com/office/drawing/2014/main" id="{77A524E0-EC6A-C748-C2C4-4527599AC6EA}"/>
+                <a16:creationId xmlns:a16="http://schemas.microsoft.com/office/drawing/2014/main" id="{F9029E8A-20C0-D00D-F77F-F1250551031B}"/>
               </a:ext>
             </a:extLst>
           </p:cNvPr>
@@ -4657,7 +5405,7 @@
           <p:cNvPr id="3" name="Slide Number Placeholder 2">
             <a:extLst>
               <a:ext uri="{FF2B5EF4-FFF2-40B4-BE49-F238E27FC236}">
-                <a16:creationId xmlns:a16="http://schemas.microsoft.com/office/drawing/2014/main" id="{7E428BE4-E698-70F3-9193-CB49B58D592B}"/>
+                <a16:creationId xmlns:a16="http://schemas.microsoft.com/office/drawing/2014/main" id="{D9E3A153-4C40-26E9-49E2-BA134379D882}"/>
               </a:ext>
             </a:extLst>
           </p:cNvPr>
@@ -4676,7 +5424,7 @@
             <a:fld id="{CAC3FE34-2808-40E6-BEA2-B7CA77D47CA5}" type="slidenum">
               <a:rPr lang="en-US" smtClean="0"/>
               <a:pPr/>
-              <a:t>8</a:t>
+              <a:t>7</a:t>
             </a:fld>
             <a:endParaRPr lang="en-US" dirty="0"/>
           </a:p>
@@ -4687,7 +5435,7 @@
           <p:cNvPr id="4" name="Text Placeholder 3">
             <a:extLst>
               <a:ext uri="{FF2B5EF4-FFF2-40B4-BE49-F238E27FC236}">
-                <a16:creationId xmlns:a16="http://schemas.microsoft.com/office/drawing/2014/main" id="{D8E2CC23-850D-6EA9-A71A-6E1607535596}"/>
+                <a16:creationId xmlns:a16="http://schemas.microsoft.com/office/drawing/2014/main" id="{65C64220-7222-02E3-1FDF-50A8664FCE5E}"/>
               </a:ext>
             </a:extLst>
           </p:cNvPr>
@@ -4723,7 +5471,7 @@
           <p:cNvPr id="5" name="Table 4">
             <a:extLst>
               <a:ext uri="{FF2B5EF4-FFF2-40B4-BE49-F238E27FC236}">
-                <a16:creationId xmlns:a16="http://schemas.microsoft.com/office/drawing/2014/main" id="{94F0AC01-B21E-B175-A1E9-A63640100764}"/>
+                <a16:creationId xmlns:a16="http://schemas.microsoft.com/office/drawing/2014/main" id="{E30714D8-41FB-E440-D5D2-F7BABF8033FC}"/>
               </a:ext>
             </a:extLst>
           </p:cNvPr>
@@ -4733,7 +5481,7 @@
           <p:nvPr/>
         </p:nvGraphicFramePr>
         <p:xfrm>
-          <a:off x="7662041" y="1995597"/>
+          <a:off x="7662041" y="2124542"/>
           <a:ext cx="3983421" cy="3774580"/>
         </p:xfrm>
         <a:graphic>
@@ -4771,7 +5519,26 @@
                       </a:r>
                     </a:p>
                   </a:txBody>
-                  <a:tcPr anchor="ctr"/>
+                  <a:tcPr anchor="ctr">
+                    <a:lnL w="12700" cap="flat" cmpd="sng" algn="ctr">
+                      <a:solidFill>
+                        <a:schemeClr val="tx1"/>
+                      </a:solidFill>
+                      <a:prstDash val="solid"/>
+                      <a:round/>
+                      <a:headEnd type="none" w="med" len="med"/>
+                      <a:tailEnd type="none" w="med" len="med"/>
+                    </a:lnL>
+                    <a:lnT w="12700" cap="flat" cmpd="sng" algn="ctr">
+                      <a:solidFill>
+                        <a:schemeClr val="tx1"/>
+                      </a:solidFill>
+                      <a:prstDash val="solid"/>
+                      <a:round/>
+                      <a:headEnd type="none" w="med" len="med"/>
+                      <a:tailEnd type="none" w="med" len="med"/>
+                    </a:lnT>
+                  </a:tcPr>
                 </a:tc>
                 <a:tc>
                   <a:txBody>
@@ -4785,7 +5552,26 @@
                       </a:r>
                     </a:p>
                   </a:txBody>
-                  <a:tcPr anchor="ctr"/>
+                  <a:tcPr anchor="ctr">
+                    <a:lnR w="12700" cap="flat" cmpd="sng" algn="ctr">
+                      <a:solidFill>
+                        <a:schemeClr val="tx1"/>
+                      </a:solidFill>
+                      <a:prstDash val="solid"/>
+                      <a:round/>
+                      <a:headEnd type="none" w="med" len="med"/>
+                      <a:tailEnd type="none" w="med" len="med"/>
+                    </a:lnR>
+                    <a:lnT w="12700" cap="flat" cmpd="sng" algn="ctr">
+                      <a:solidFill>
+                        <a:schemeClr val="tx1"/>
+                      </a:solidFill>
+                      <a:prstDash val="solid"/>
+                      <a:round/>
+                      <a:headEnd type="none" w="med" len="med"/>
+                      <a:tailEnd type="none" w="med" len="med"/>
+                    </a:lnT>
+                  </a:tcPr>
                 </a:tc>
                 <a:extLst>
                   <a:ext uri="{0D108BD9-81ED-4DB2-BD59-A6C34878D82A}">
@@ -4806,7 +5592,17 @@
                       </a:r>
                     </a:p>
                   </a:txBody>
-                  <a:tcPr anchor="ctr"/>
+                  <a:tcPr anchor="ctr">
+                    <a:lnL w="12700" cap="flat" cmpd="sng" algn="ctr">
+                      <a:solidFill>
+                        <a:schemeClr val="tx1"/>
+                      </a:solidFill>
+                      <a:prstDash val="solid"/>
+                      <a:round/>
+                      <a:headEnd type="none" w="med" len="med"/>
+                      <a:tailEnd type="none" w="med" len="med"/>
+                    </a:lnL>
+                  </a:tcPr>
                 </a:tc>
                 <a:tc>
                   <a:txBody>
@@ -4820,7 +5616,17 @@
                       </a:r>
                     </a:p>
                   </a:txBody>
-                  <a:tcPr anchor="ctr"/>
+                  <a:tcPr anchor="ctr">
+                    <a:lnR w="12700" cap="flat" cmpd="sng" algn="ctr">
+                      <a:solidFill>
+                        <a:schemeClr val="tx1"/>
+                      </a:solidFill>
+                      <a:prstDash val="solid"/>
+                      <a:round/>
+                      <a:headEnd type="none" w="med" len="med"/>
+                      <a:tailEnd type="none" w="med" len="med"/>
+                    </a:lnR>
+                  </a:tcPr>
                 </a:tc>
                 <a:extLst>
                   <a:ext uri="{0D108BD9-81ED-4DB2-BD59-A6C34878D82A}">
@@ -4841,7 +5647,17 @@
                       </a:r>
                     </a:p>
                   </a:txBody>
-                  <a:tcPr anchor="ctr"/>
+                  <a:tcPr anchor="ctr">
+                    <a:lnL w="12700" cap="flat" cmpd="sng" algn="ctr">
+                      <a:solidFill>
+                        <a:schemeClr val="tx1"/>
+                      </a:solidFill>
+                      <a:prstDash val="solid"/>
+                      <a:round/>
+                      <a:headEnd type="none" w="med" len="med"/>
+                      <a:tailEnd type="none" w="med" len="med"/>
+                    </a:lnL>
+                  </a:tcPr>
                 </a:tc>
                 <a:tc>
                   <a:txBody>
@@ -4855,7 +5671,17 @@
                       </a:r>
                     </a:p>
                   </a:txBody>
-                  <a:tcPr anchor="ctr"/>
+                  <a:tcPr anchor="ctr">
+                    <a:lnR w="12700" cap="flat" cmpd="sng" algn="ctr">
+                      <a:solidFill>
+                        <a:schemeClr val="tx1"/>
+                      </a:solidFill>
+                      <a:prstDash val="solid"/>
+                      <a:round/>
+                      <a:headEnd type="none" w="med" len="med"/>
+                      <a:tailEnd type="none" w="med" len="med"/>
+                    </a:lnR>
+                  </a:tcPr>
                 </a:tc>
                 <a:extLst>
                   <a:ext uri="{0D108BD9-81ED-4DB2-BD59-A6C34878D82A}">
@@ -4876,7 +5702,17 @@
                       </a:r>
                     </a:p>
                   </a:txBody>
-                  <a:tcPr anchor="ctr"/>
+                  <a:tcPr anchor="ctr">
+                    <a:lnL w="12700" cap="flat" cmpd="sng" algn="ctr">
+                      <a:solidFill>
+                        <a:schemeClr val="tx1"/>
+                      </a:solidFill>
+                      <a:prstDash val="solid"/>
+                      <a:round/>
+                      <a:headEnd type="none" w="med" len="med"/>
+                      <a:tailEnd type="none" w="med" len="med"/>
+                    </a:lnL>
+                  </a:tcPr>
                 </a:tc>
                 <a:tc>
                   <a:txBody>
@@ -4890,7 +5726,17 @@
                       </a:r>
                     </a:p>
                   </a:txBody>
-                  <a:tcPr anchor="ctr"/>
+                  <a:tcPr anchor="ctr">
+                    <a:lnR w="12700" cap="flat" cmpd="sng" algn="ctr">
+                      <a:solidFill>
+                        <a:schemeClr val="tx1"/>
+                      </a:solidFill>
+                      <a:prstDash val="solid"/>
+                      <a:round/>
+                      <a:headEnd type="none" w="med" len="med"/>
+                      <a:tailEnd type="none" w="med" len="med"/>
+                    </a:lnR>
+                  </a:tcPr>
                 </a:tc>
                 <a:extLst>
                   <a:ext uri="{0D108BD9-81ED-4DB2-BD59-A6C34878D82A}">
@@ -4911,7 +5757,17 @@
                       </a:r>
                     </a:p>
                   </a:txBody>
-                  <a:tcPr anchor="ctr"/>
+                  <a:tcPr anchor="ctr">
+                    <a:lnL w="12700" cap="flat" cmpd="sng" algn="ctr">
+                      <a:solidFill>
+                        <a:schemeClr val="tx1"/>
+                      </a:solidFill>
+                      <a:prstDash val="solid"/>
+                      <a:round/>
+                      <a:headEnd type="none" w="med" len="med"/>
+                      <a:tailEnd type="none" w="med" len="med"/>
+                    </a:lnL>
+                  </a:tcPr>
                 </a:tc>
                 <a:tc>
                   <a:txBody>
@@ -4925,7 +5781,17 @@
                       </a:r>
                     </a:p>
                   </a:txBody>
-                  <a:tcPr anchor="ctr"/>
+                  <a:tcPr anchor="ctr">
+                    <a:lnR w="12700" cap="flat" cmpd="sng" algn="ctr">
+                      <a:solidFill>
+                        <a:schemeClr val="tx1"/>
+                      </a:solidFill>
+                      <a:prstDash val="solid"/>
+                      <a:round/>
+                      <a:headEnd type="none" w="med" len="med"/>
+                      <a:tailEnd type="none" w="med" len="med"/>
+                    </a:lnR>
+                  </a:tcPr>
                 </a:tc>
                 <a:extLst>
                   <a:ext uri="{0D108BD9-81ED-4DB2-BD59-A6C34878D82A}">
@@ -4946,7 +5812,17 @@
                       </a:r>
                     </a:p>
                   </a:txBody>
-                  <a:tcPr anchor="ctr"/>
+                  <a:tcPr anchor="ctr">
+                    <a:lnL w="12700" cap="flat" cmpd="sng" algn="ctr">
+                      <a:solidFill>
+                        <a:schemeClr val="tx1"/>
+                      </a:solidFill>
+                      <a:prstDash val="solid"/>
+                      <a:round/>
+                      <a:headEnd type="none" w="med" len="med"/>
+                      <a:tailEnd type="none" w="med" len="med"/>
+                    </a:lnL>
+                  </a:tcPr>
                 </a:tc>
                 <a:tc>
                   <a:txBody>
@@ -4960,7 +5836,17 @@
                       </a:r>
                     </a:p>
                   </a:txBody>
-                  <a:tcPr anchor="ctr"/>
+                  <a:tcPr anchor="ctr">
+                    <a:lnR w="12700" cap="flat" cmpd="sng" algn="ctr">
+                      <a:solidFill>
+                        <a:schemeClr val="tx1"/>
+                      </a:solidFill>
+                      <a:prstDash val="solid"/>
+                      <a:round/>
+                      <a:headEnd type="none" w="med" len="med"/>
+                      <a:tailEnd type="none" w="med" len="med"/>
+                    </a:lnR>
+                  </a:tcPr>
                 </a:tc>
                 <a:extLst>
                   <a:ext uri="{0D108BD9-81ED-4DB2-BD59-A6C34878D82A}">
@@ -4981,7 +5867,26 @@
                       </a:r>
                     </a:p>
                   </a:txBody>
-                  <a:tcPr anchor="ctr"/>
+                  <a:tcPr anchor="ctr">
+                    <a:lnL w="12700" cap="flat" cmpd="sng" algn="ctr">
+                      <a:solidFill>
+                        <a:schemeClr val="tx1"/>
+                      </a:solidFill>
+                      <a:prstDash val="solid"/>
+                      <a:round/>
+                      <a:headEnd type="none" w="med" len="med"/>
+                      <a:tailEnd type="none" w="med" len="med"/>
+                    </a:lnL>
+                    <a:lnB w="12700" cap="flat" cmpd="sng" algn="ctr">
+                      <a:solidFill>
+                        <a:schemeClr val="tx1"/>
+                      </a:solidFill>
+                      <a:prstDash val="solid"/>
+                      <a:round/>
+                      <a:headEnd type="none" w="med" len="med"/>
+                      <a:tailEnd type="none" w="med" len="med"/>
+                    </a:lnB>
+                  </a:tcPr>
                 </a:tc>
                 <a:tc>
                   <a:txBody>
@@ -4996,7 +5901,26 @@
                       <a:endParaRPr lang="en-US" sz="1800" dirty="0"/>
                     </a:p>
                   </a:txBody>
-                  <a:tcPr anchor="ctr"/>
+                  <a:tcPr anchor="ctr">
+                    <a:lnR w="12700" cap="flat" cmpd="sng" algn="ctr">
+                      <a:solidFill>
+                        <a:schemeClr val="tx1"/>
+                      </a:solidFill>
+                      <a:prstDash val="solid"/>
+                      <a:round/>
+                      <a:headEnd type="none" w="med" len="med"/>
+                      <a:tailEnd type="none" w="med" len="med"/>
+                    </a:lnR>
+                    <a:lnB w="12700" cap="flat" cmpd="sng" algn="ctr">
+                      <a:solidFill>
+                        <a:schemeClr val="tx1"/>
+                      </a:solidFill>
+                      <a:prstDash val="solid"/>
+                      <a:round/>
+                      <a:headEnd type="none" w="med" len="med"/>
+                      <a:tailEnd type="none" w="med" len="med"/>
+                    </a:lnB>
+                  </a:tcPr>
                 </a:tc>
                 <a:extLst>
                   <a:ext uri="{0D108BD9-81ED-4DB2-BD59-A6C34878D82A}">
@@ -5013,7 +5937,7 @@
           <p:cNvPr id="7" name="Picture 6" descr="A graph of a graph&#10;&#10;AI-generated content may be incorrect.">
             <a:extLst>
               <a:ext uri="{FF2B5EF4-FFF2-40B4-BE49-F238E27FC236}">
-                <a16:creationId xmlns:a16="http://schemas.microsoft.com/office/drawing/2014/main" id="{3E68ECAF-C9C2-F063-5830-E59E12A56103}"/>
+                <a16:creationId xmlns:a16="http://schemas.microsoft.com/office/drawing/2014/main" id="{3C5128D4-E015-6C63-E30A-A85B90A311E9}"/>
               </a:ext>
             </a:extLst>
           </p:cNvPr>
@@ -5036,44 +5960,8 @@
         </p:blipFill>
         <p:spPr>
           <a:xfrm>
-            <a:off x="1250731" y="2475052"/>
-            <a:ext cx="5139559" cy="3778111"/>
-          </a:xfrm>
-          <a:prstGeom prst="rect">
-            <a:avLst/>
-          </a:prstGeom>
-        </p:spPr>
-      </p:pic>
-      <p:pic>
-        <p:nvPicPr>
-          <p:cNvPr id="9" name="Picture 8" descr="A graph of a sphere with red and blue lines&#10;&#10;AI-generated content may be incorrect.">
-            <a:extLst>
-              <a:ext uri="{FF2B5EF4-FFF2-40B4-BE49-F238E27FC236}">
-                <a16:creationId xmlns:a16="http://schemas.microsoft.com/office/drawing/2014/main" id="{3D109418-A254-5356-58BD-C7A235E5D60F}"/>
-              </a:ext>
-            </a:extLst>
-          </p:cNvPr>
-          <p:cNvPicPr>
-            <a:picLocks noChangeAspect="1"/>
-          </p:cNvPicPr>
-          <p:nvPr/>
-        </p:nvPicPr>
-        <p:blipFill>
-          <a:blip r:embed="rId3" cstate="print">
-            <a:extLst>
-              <a:ext uri="{28A0092B-C50C-407E-A947-70E740481C1C}">
-                <a14:useLocalDpi xmlns:a14="http://schemas.microsoft.com/office/drawing/2010/main" val="0"/>
-              </a:ext>
-            </a:extLst>
-          </a:blip>
-          <a:stretch>
-            <a:fillRect/>
-          </a:stretch>
-        </p:blipFill>
-        <p:spPr>
-          <a:xfrm>
-            <a:off x="1125083" y="2451596"/>
-            <a:ext cx="5338938" cy="3801567"/>
+            <a:off x="747150" y="2396751"/>
+            <a:ext cx="5914395" cy="4347696"/>
           </a:xfrm>
           <a:prstGeom prst="rect">
             <a:avLst/>
@@ -5085,7 +5973,7 @@
           <p:cNvPr id="6" name="Text Placeholder 3">
             <a:extLst>
               <a:ext uri="{FF2B5EF4-FFF2-40B4-BE49-F238E27FC236}">
-                <a16:creationId xmlns:a16="http://schemas.microsoft.com/office/drawing/2014/main" id="{035EA581-D510-FDAF-1BAA-20FAEFE41226}"/>
+                <a16:creationId xmlns:a16="http://schemas.microsoft.com/office/drawing/2014/main" id="{CBEB6D77-8D7A-C995-729E-DFFA1B64B6CA}"/>
               </a:ext>
             </a:extLst>
           </p:cNvPr>
@@ -5319,28 +6207,64 @@
           </a:p>
         </p:txBody>
       </p:sp>
+      <p:pic>
+        <p:nvPicPr>
+          <p:cNvPr id="8" name="Picture 7" descr="A graph of a sphere with red and blue lines&#10;&#10;AI-generated content may be incorrect.">
+            <a:extLst>
+              <a:ext uri="{FF2B5EF4-FFF2-40B4-BE49-F238E27FC236}">
+                <a16:creationId xmlns:a16="http://schemas.microsoft.com/office/drawing/2014/main" id="{8FD4AC00-0BC5-CE45-4A03-07709121D22F}"/>
+              </a:ext>
+            </a:extLst>
+          </p:cNvPr>
+          <p:cNvPicPr>
+            <a:picLocks noChangeAspect="1"/>
+          </p:cNvPicPr>
+          <p:nvPr/>
+        </p:nvPicPr>
+        <p:blipFill>
+          <a:blip r:embed="rId3" cstate="print">
+            <a:extLst>
+              <a:ext uri="{28A0092B-C50C-407E-A947-70E740481C1C}">
+                <a14:useLocalDpi xmlns:a14="http://schemas.microsoft.com/office/drawing/2010/main" val="0"/>
+              </a:ext>
+            </a:extLst>
+          </a:blip>
+          <a:stretch>
+            <a:fillRect/>
+          </a:stretch>
+        </p:blipFill>
+        <p:spPr>
+          <a:xfrm>
+            <a:off x="746003" y="2396751"/>
+            <a:ext cx="6105924" cy="4347696"/>
+          </a:xfrm>
+          <a:prstGeom prst="rect">
+            <a:avLst/>
+          </a:prstGeom>
+        </p:spPr>
+      </p:pic>
     </p:spTree>
     <p:extLst>
       <p:ext uri="{BB962C8B-B14F-4D97-AF65-F5344CB8AC3E}">
-        <p14:creationId xmlns:p14="http://schemas.microsoft.com/office/powerpoint/2010/main" val="729443008"/>
+        <p14:creationId xmlns:p14="http://schemas.microsoft.com/office/powerpoint/2010/main" val="1388642492"/>
       </p:ext>
     </p:extLst>
   </p:cSld>
   <p:clrMapOvr>
     <a:masterClrMapping/>
   </p:clrMapOvr>
-  <mc:AlternateContent xmlns:mc="http://schemas.openxmlformats.org/markup-compatibility/2006">
-    <mc:Choice xmlns:p14="http://schemas.microsoft.com/office/powerpoint/2010/main" Requires="p14">
+  <mc:AlternateContent xmlns:mc="http://schemas.openxmlformats.org/markup-compatibility/2006" xmlns:p14="http://schemas.microsoft.com/office/powerpoint/2010/main">
+    <mc:Choice Requires="p14">
       <p:transition p14:dur="0"/>
     </mc:Choice>
-    <mc:Fallback>
+    <mc:Fallback xmlns="">
       <p:transition/>
     </mc:Fallback>
   </mc:AlternateContent>
 </p:sld>
 </file>
 
-<file path=ppt/slides/slide9.xml><?xml version="1.0" encoding="utf-8"?>
+<file path=ppt/slides/slide8.xml><?xml version="1.0" encoding="utf-8"?>
 <p:sld xmlns:a="http://schemas.openxmlformats.org/drawingml/2006/main" xmlns:r="http://schemas.openxmlformats.org/officeDocument/2006/relationships" xmlns:p="http://schemas.openxmlformats.org/presentationml/2006/main">
   <p:cSld>
     <p:spTree>
@@ -5348,7 +6272,7 @@
         <p:cNvPr id="1" name="">
           <a:extLst>
             <a:ext uri="{FF2B5EF4-FFF2-40B4-BE49-F238E27FC236}">
-              <a16:creationId xmlns:a16="http://schemas.microsoft.com/office/drawing/2014/main" id="{C55B2F9C-B466-38DF-02C3-26C639907086}"/>
+              <a16:creationId xmlns:a16="http://schemas.microsoft.com/office/drawing/2014/main" id="{C2AAAEEF-9701-7A83-39CD-8CDC55E87402}"/>
             </a:ext>
           </a:extLst>
         </p:cNvPr>
@@ -5368,7 +6292,7 @@
           <p:cNvPr id="2" name="Title 1">
             <a:extLst>
               <a:ext uri="{FF2B5EF4-FFF2-40B4-BE49-F238E27FC236}">
-                <a16:creationId xmlns:a16="http://schemas.microsoft.com/office/drawing/2014/main" id="{AB572516-A288-40AD-8261-7C89BF35654D}"/>
+                <a16:creationId xmlns:a16="http://schemas.microsoft.com/office/drawing/2014/main" id="{8B632337-4FFC-AAE5-62AE-B507AE096DF8}"/>
               </a:ext>
             </a:extLst>
           </p:cNvPr>
@@ -5396,7 +6320,7 @@
           <p:cNvPr id="3" name="Slide Number Placeholder 2">
             <a:extLst>
               <a:ext uri="{FF2B5EF4-FFF2-40B4-BE49-F238E27FC236}">
-                <a16:creationId xmlns:a16="http://schemas.microsoft.com/office/drawing/2014/main" id="{BC398AE0-DFE8-4740-7C8C-376680B31C3E}"/>
+                <a16:creationId xmlns:a16="http://schemas.microsoft.com/office/drawing/2014/main" id="{8AA9AF3E-FC4A-9D1F-7F73-00A60480860D}"/>
               </a:ext>
             </a:extLst>
           </p:cNvPr>
@@ -5415,7 +6339,7 @@
             <a:fld id="{CAC3FE34-2808-40E6-BEA2-B7CA77D47CA5}" type="slidenum">
               <a:rPr lang="en-US" smtClean="0"/>
               <a:pPr/>
-              <a:t>9</a:t>
+              <a:t>8</a:t>
             </a:fld>
             <a:endParaRPr lang="en-US" dirty="0"/>
           </a:p>
@@ -5426,7 +6350,7 @@
           <p:cNvPr id="4" name="Text Placeholder 3">
             <a:extLst>
               <a:ext uri="{FF2B5EF4-FFF2-40B4-BE49-F238E27FC236}">
-                <a16:creationId xmlns:a16="http://schemas.microsoft.com/office/drawing/2014/main" id="{0ED60E65-1603-A798-9DC2-DF73B17DAE29}"/>
+                <a16:creationId xmlns:a16="http://schemas.microsoft.com/office/drawing/2014/main" id="{4D20C184-C5DE-B925-630D-BBC296BE17EA}"/>
               </a:ext>
             </a:extLst>
           </p:cNvPr>
@@ -5462,7 +6386,7 @@
           <p:cNvPr id="5" name="Table 4">
             <a:extLst>
               <a:ext uri="{FF2B5EF4-FFF2-40B4-BE49-F238E27FC236}">
-                <a16:creationId xmlns:a16="http://schemas.microsoft.com/office/drawing/2014/main" id="{028E4F10-CFAB-F7FB-E61F-C9F1A832C708}"/>
+                <a16:creationId xmlns:a16="http://schemas.microsoft.com/office/drawing/2014/main" id="{62AE8999-54E7-1AAB-C82E-AADBD621FAD9}"/>
               </a:ext>
             </a:extLst>
           </p:cNvPr>
@@ -5472,7 +6396,7 @@
           <p:nvPr/>
         </p:nvGraphicFramePr>
         <p:xfrm>
-          <a:off x="7662041" y="1995597"/>
+          <a:off x="7662041" y="2124542"/>
           <a:ext cx="3983421" cy="3774580"/>
         </p:xfrm>
         <a:graphic>
@@ -5510,7 +6434,26 @@
                       </a:r>
                     </a:p>
                   </a:txBody>
-                  <a:tcPr anchor="ctr"/>
+                  <a:tcPr anchor="ctr">
+                    <a:lnL w="12700" cap="flat" cmpd="sng" algn="ctr">
+                      <a:solidFill>
+                        <a:schemeClr val="tx1"/>
+                      </a:solidFill>
+                      <a:prstDash val="solid"/>
+                      <a:round/>
+                      <a:headEnd type="none" w="med" len="med"/>
+                      <a:tailEnd type="none" w="med" len="med"/>
+                    </a:lnL>
+                    <a:lnT w="12700" cap="flat" cmpd="sng" algn="ctr">
+                      <a:solidFill>
+                        <a:schemeClr val="tx1"/>
+                      </a:solidFill>
+                      <a:prstDash val="solid"/>
+                      <a:round/>
+                      <a:headEnd type="none" w="med" len="med"/>
+                      <a:tailEnd type="none" w="med" len="med"/>
+                    </a:lnT>
+                  </a:tcPr>
                 </a:tc>
                 <a:tc>
                   <a:txBody>
@@ -5524,7 +6467,26 @@
                       </a:r>
                     </a:p>
                   </a:txBody>
-                  <a:tcPr anchor="ctr"/>
+                  <a:tcPr anchor="ctr">
+                    <a:lnR w="12700" cap="flat" cmpd="sng" algn="ctr">
+                      <a:solidFill>
+                        <a:schemeClr val="tx1"/>
+                      </a:solidFill>
+                      <a:prstDash val="solid"/>
+                      <a:round/>
+                      <a:headEnd type="none" w="med" len="med"/>
+                      <a:tailEnd type="none" w="med" len="med"/>
+                    </a:lnR>
+                    <a:lnT w="12700" cap="flat" cmpd="sng" algn="ctr">
+                      <a:solidFill>
+                        <a:schemeClr val="tx1"/>
+                      </a:solidFill>
+                      <a:prstDash val="solid"/>
+                      <a:round/>
+                      <a:headEnd type="none" w="med" len="med"/>
+                      <a:tailEnd type="none" w="med" len="med"/>
+                    </a:lnT>
+                  </a:tcPr>
                 </a:tc>
                 <a:extLst>
                   <a:ext uri="{0D108BD9-81ED-4DB2-BD59-A6C34878D82A}">
@@ -5545,7 +6507,17 @@
                       </a:r>
                     </a:p>
                   </a:txBody>
-                  <a:tcPr anchor="ctr"/>
+                  <a:tcPr anchor="ctr">
+                    <a:lnL w="12700" cap="flat" cmpd="sng" algn="ctr">
+                      <a:solidFill>
+                        <a:schemeClr val="tx1"/>
+                      </a:solidFill>
+                      <a:prstDash val="solid"/>
+                      <a:round/>
+                      <a:headEnd type="none" w="med" len="med"/>
+                      <a:tailEnd type="none" w="med" len="med"/>
+                    </a:lnL>
+                  </a:tcPr>
                 </a:tc>
                 <a:tc>
                   <a:txBody>
@@ -5559,7 +6531,17 @@
                       </a:r>
                     </a:p>
                   </a:txBody>
-                  <a:tcPr anchor="ctr"/>
+                  <a:tcPr anchor="ctr">
+                    <a:lnR w="12700" cap="flat" cmpd="sng" algn="ctr">
+                      <a:solidFill>
+                        <a:schemeClr val="tx1"/>
+                      </a:solidFill>
+                      <a:prstDash val="solid"/>
+                      <a:round/>
+                      <a:headEnd type="none" w="med" len="med"/>
+                      <a:tailEnd type="none" w="med" len="med"/>
+                    </a:lnR>
+                  </a:tcPr>
                 </a:tc>
                 <a:extLst>
                   <a:ext uri="{0D108BD9-81ED-4DB2-BD59-A6C34878D82A}">
@@ -5580,7 +6562,17 @@
                       </a:r>
                     </a:p>
                   </a:txBody>
-                  <a:tcPr anchor="ctr"/>
+                  <a:tcPr anchor="ctr">
+                    <a:lnL w="12700" cap="flat" cmpd="sng" algn="ctr">
+                      <a:solidFill>
+                        <a:schemeClr val="tx1"/>
+                      </a:solidFill>
+                      <a:prstDash val="solid"/>
+                      <a:round/>
+                      <a:headEnd type="none" w="med" len="med"/>
+                      <a:tailEnd type="none" w="med" len="med"/>
+                    </a:lnL>
+                  </a:tcPr>
                 </a:tc>
                 <a:tc>
                   <a:txBody>
@@ -5594,7 +6586,17 @@
                       </a:r>
                     </a:p>
                   </a:txBody>
-                  <a:tcPr anchor="ctr"/>
+                  <a:tcPr anchor="ctr">
+                    <a:lnR w="12700" cap="flat" cmpd="sng" algn="ctr">
+                      <a:solidFill>
+                        <a:schemeClr val="tx1"/>
+                      </a:solidFill>
+                      <a:prstDash val="solid"/>
+                      <a:round/>
+                      <a:headEnd type="none" w="med" len="med"/>
+                      <a:tailEnd type="none" w="med" len="med"/>
+                    </a:lnR>
+                  </a:tcPr>
                 </a:tc>
                 <a:extLst>
                   <a:ext uri="{0D108BD9-81ED-4DB2-BD59-A6C34878D82A}">
@@ -5615,7 +6617,17 @@
                       </a:r>
                     </a:p>
                   </a:txBody>
-                  <a:tcPr anchor="ctr"/>
+                  <a:tcPr anchor="ctr">
+                    <a:lnL w="12700" cap="flat" cmpd="sng" algn="ctr">
+                      <a:solidFill>
+                        <a:schemeClr val="tx1"/>
+                      </a:solidFill>
+                      <a:prstDash val="solid"/>
+                      <a:round/>
+                      <a:headEnd type="none" w="med" len="med"/>
+                      <a:tailEnd type="none" w="med" len="med"/>
+                    </a:lnL>
+                  </a:tcPr>
                 </a:tc>
                 <a:tc>
                   <a:txBody>
@@ -5629,7 +6641,17 @@
                       </a:r>
                     </a:p>
                   </a:txBody>
-                  <a:tcPr anchor="ctr"/>
+                  <a:tcPr anchor="ctr">
+                    <a:lnR w="12700" cap="flat" cmpd="sng" algn="ctr">
+                      <a:solidFill>
+                        <a:schemeClr val="tx1"/>
+                      </a:solidFill>
+                      <a:prstDash val="solid"/>
+                      <a:round/>
+                      <a:headEnd type="none" w="med" len="med"/>
+                      <a:tailEnd type="none" w="med" len="med"/>
+                    </a:lnR>
+                  </a:tcPr>
                 </a:tc>
                 <a:extLst>
                   <a:ext uri="{0D108BD9-81ED-4DB2-BD59-A6C34878D82A}">
@@ -5650,7 +6672,17 @@
                       </a:r>
                     </a:p>
                   </a:txBody>
-                  <a:tcPr anchor="ctr"/>
+                  <a:tcPr anchor="ctr">
+                    <a:lnL w="12700" cap="flat" cmpd="sng" algn="ctr">
+                      <a:solidFill>
+                        <a:schemeClr val="tx1"/>
+                      </a:solidFill>
+                      <a:prstDash val="solid"/>
+                      <a:round/>
+                      <a:headEnd type="none" w="med" len="med"/>
+                      <a:tailEnd type="none" w="med" len="med"/>
+                    </a:lnL>
+                  </a:tcPr>
                 </a:tc>
                 <a:tc>
                   <a:txBody>
@@ -5664,7 +6696,17 @@
                       </a:r>
                     </a:p>
                   </a:txBody>
-                  <a:tcPr anchor="ctr"/>
+                  <a:tcPr anchor="ctr">
+                    <a:lnR w="12700" cap="flat" cmpd="sng" algn="ctr">
+                      <a:solidFill>
+                        <a:schemeClr val="tx1"/>
+                      </a:solidFill>
+                      <a:prstDash val="solid"/>
+                      <a:round/>
+                      <a:headEnd type="none" w="med" len="med"/>
+                      <a:tailEnd type="none" w="med" len="med"/>
+                    </a:lnR>
+                  </a:tcPr>
                 </a:tc>
                 <a:extLst>
                   <a:ext uri="{0D108BD9-81ED-4DB2-BD59-A6C34878D82A}">
@@ -5685,7 +6727,17 @@
                       </a:r>
                     </a:p>
                   </a:txBody>
-                  <a:tcPr anchor="ctr"/>
+                  <a:tcPr anchor="ctr">
+                    <a:lnL w="12700" cap="flat" cmpd="sng" algn="ctr">
+                      <a:solidFill>
+                        <a:schemeClr val="tx1"/>
+                      </a:solidFill>
+                      <a:prstDash val="solid"/>
+                      <a:round/>
+                      <a:headEnd type="none" w="med" len="med"/>
+                      <a:tailEnd type="none" w="med" len="med"/>
+                    </a:lnL>
+                  </a:tcPr>
                 </a:tc>
                 <a:tc>
                   <a:txBody>
@@ -5699,7 +6751,17 @@
                       </a:r>
                     </a:p>
                   </a:txBody>
-                  <a:tcPr anchor="ctr"/>
+                  <a:tcPr anchor="ctr">
+                    <a:lnR w="12700" cap="flat" cmpd="sng" algn="ctr">
+                      <a:solidFill>
+                        <a:schemeClr val="tx1"/>
+                      </a:solidFill>
+                      <a:prstDash val="solid"/>
+                      <a:round/>
+                      <a:headEnd type="none" w="med" len="med"/>
+                      <a:tailEnd type="none" w="med" len="med"/>
+                    </a:lnR>
+                  </a:tcPr>
                 </a:tc>
                 <a:extLst>
                   <a:ext uri="{0D108BD9-81ED-4DB2-BD59-A6C34878D82A}">
@@ -5720,7 +6782,26 @@
                       </a:r>
                     </a:p>
                   </a:txBody>
-                  <a:tcPr anchor="ctr"/>
+                  <a:tcPr anchor="ctr">
+                    <a:lnL w="12700" cap="flat" cmpd="sng" algn="ctr">
+                      <a:solidFill>
+                        <a:schemeClr val="tx1"/>
+                      </a:solidFill>
+                      <a:prstDash val="solid"/>
+                      <a:round/>
+                      <a:headEnd type="none" w="med" len="med"/>
+                      <a:tailEnd type="none" w="med" len="med"/>
+                    </a:lnL>
+                    <a:lnB w="12700" cap="flat" cmpd="sng" algn="ctr">
+                      <a:solidFill>
+                        <a:schemeClr val="tx1"/>
+                      </a:solidFill>
+                      <a:prstDash val="solid"/>
+                      <a:round/>
+                      <a:headEnd type="none" w="med" len="med"/>
+                      <a:tailEnd type="none" w="med" len="med"/>
+                    </a:lnB>
+                  </a:tcPr>
                 </a:tc>
                 <a:tc>
                   <a:txBody>
@@ -5735,7 +6816,26 @@
                       <a:endParaRPr lang="en-US" sz="1800" dirty="0"/>
                     </a:p>
                   </a:txBody>
-                  <a:tcPr anchor="ctr"/>
+                  <a:tcPr anchor="ctr">
+                    <a:lnR w="12700" cap="flat" cmpd="sng" algn="ctr">
+                      <a:solidFill>
+                        <a:schemeClr val="tx1"/>
+                      </a:solidFill>
+                      <a:prstDash val="solid"/>
+                      <a:round/>
+                      <a:headEnd type="none" w="med" len="med"/>
+                      <a:tailEnd type="none" w="med" len="med"/>
+                    </a:lnR>
+                    <a:lnB w="12700" cap="flat" cmpd="sng" algn="ctr">
+                      <a:solidFill>
+                        <a:schemeClr val="tx1"/>
+                      </a:solidFill>
+                      <a:prstDash val="solid"/>
+                      <a:round/>
+                      <a:headEnd type="none" w="med" len="med"/>
+                      <a:tailEnd type="none" w="med" len="med"/>
+                    </a:lnB>
+                  </a:tcPr>
                 </a:tc>
                 <a:extLst>
                   <a:ext uri="{0D108BD9-81ED-4DB2-BD59-A6C34878D82A}">
@@ -5752,7 +6852,7 @@
           <p:cNvPr id="7" name="Picture 6" descr="A graph of a graph&#10;&#10;AI-generated content may be incorrect.">
             <a:extLst>
               <a:ext uri="{FF2B5EF4-FFF2-40B4-BE49-F238E27FC236}">
-                <a16:creationId xmlns:a16="http://schemas.microsoft.com/office/drawing/2014/main" id="{570E749A-0A40-755D-DC12-0AC56C206467}"/>
+                <a16:creationId xmlns:a16="http://schemas.microsoft.com/office/drawing/2014/main" id="{C6F1EB61-8203-4E1A-9781-906336FAC618}"/>
               </a:ext>
             </a:extLst>
           </p:cNvPr>
@@ -5775,8 +6875,8 @@
         </p:blipFill>
         <p:spPr>
           <a:xfrm>
-            <a:off x="1250731" y="2475052"/>
-            <a:ext cx="5139559" cy="3778111"/>
+            <a:off x="747150" y="2396751"/>
+            <a:ext cx="5914395" cy="4347696"/>
           </a:xfrm>
           <a:prstGeom prst="rect">
             <a:avLst/>
@@ -5788,7 +6888,7 @@
           <p:cNvPr id="6" name="Text Placeholder 3">
             <a:extLst>
               <a:ext uri="{FF2B5EF4-FFF2-40B4-BE49-F238E27FC236}">
-                <a16:creationId xmlns:a16="http://schemas.microsoft.com/office/drawing/2014/main" id="{007E087D-801D-28DB-D3C9-7F6654E1155B}"/>
+                <a16:creationId xmlns:a16="http://schemas.microsoft.com/office/drawing/2014/main" id="{1462736C-A763-1EAF-9247-38D07598D989}"/>
               </a:ext>
             </a:extLst>
           </p:cNvPr>
@@ -6025,25 +7125,257 @@
     </p:spTree>
     <p:extLst>
       <p:ext uri="{BB962C8B-B14F-4D97-AF65-F5344CB8AC3E}">
-        <p14:creationId xmlns:p14="http://schemas.microsoft.com/office/powerpoint/2010/main" val="82736745"/>
+        <p14:creationId xmlns:p14="http://schemas.microsoft.com/office/powerpoint/2010/main" val="1134685821"/>
       </p:ext>
     </p:extLst>
   </p:cSld>
   <p:clrMapOvr>
     <a:masterClrMapping/>
   </p:clrMapOvr>
-  <mc:AlternateContent xmlns:mc="http://schemas.openxmlformats.org/markup-compatibility/2006">
-    <mc:Choice xmlns:p159="http://schemas.microsoft.com/office/powerpoint/2015/09/main" Requires="p159">
+  <mc:AlternateContent xmlns:mc="http://schemas.openxmlformats.org/markup-compatibility/2006" xmlns:p159="http://schemas.microsoft.com/office/powerpoint/2015/09/main">
+    <mc:Choice Requires="p159">
       <p:transition xmlns:p14="http://schemas.microsoft.com/office/powerpoint/2010/main" spd="slow" p14:dur="2000">
         <p159:morph option="byObject"/>
       </p:transition>
     </mc:Choice>
-    <mc:Fallback>
+    <mc:Fallback xmlns="">
       <p:transition spd="slow">
         <p:fade/>
       </p:transition>
     </mc:Fallback>
   </mc:AlternateContent>
+</p:sld>
+</file>
+
+<file path=ppt/slides/slide9.xml><?xml version="1.0" encoding="utf-8"?>
+<p:sld xmlns:a="http://schemas.openxmlformats.org/drawingml/2006/main" xmlns:r="http://schemas.openxmlformats.org/officeDocument/2006/relationships" xmlns:p="http://schemas.openxmlformats.org/presentationml/2006/main">
+  <p:cSld>
+    <p:spTree>
+      <p:nvGrpSpPr>
+        <p:cNvPr id="1" name="">
+          <a:extLst>
+            <a:ext uri="{FF2B5EF4-FFF2-40B4-BE49-F238E27FC236}">
+              <a16:creationId xmlns:a16="http://schemas.microsoft.com/office/drawing/2014/main" id="{D64760F8-5DEB-E8BA-7337-17439833DC80}"/>
+            </a:ext>
+          </a:extLst>
+        </p:cNvPr>
+        <p:cNvGrpSpPr/>
+        <p:nvPr/>
+      </p:nvGrpSpPr>
+      <p:grpSpPr>
+        <a:xfrm>
+          <a:off x="0" y="0"/>
+          <a:ext cx="0" cy="0"/>
+          <a:chOff x="0" y="0"/>
+          <a:chExt cx="0" cy="0"/>
+        </a:xfrm>
+      </p:grpSpPr>
+      <p:sp>
+        <p:nvSpPr>
+          <p:cNvPr id="2" name="Title 1">
+            <a:extLst>
+              <a:ext uri="{FF2B5EF4-FFF2-40B4-BE49-F238E27FC236}">
+                <a16:creationId xmlns:a16="http://schemas.microsoft.com/office/drawing/2014/main" id="{40CAE30E-9FDE-1568-0D39-70DE5F5315EE}"/>
+              </a:ext>
+            </a:extLst>
+          </p:cNvPr>
+          <p:cNvSpPr>
+            <a:spLocks noGrp="1"/>
+          </p:cNvSpPr>
+          <p:nvPr>
+            <p:ph type="title"/>
+          </p:nvPr>
+        </p:nvSpPr>
+        <p:spPr/>
+        <p:txBody>
+          <a:bodyPr/>
+          <a:lstStyle/>
+          <a:p>
+            <a:r>
+              <a:rPr lang="en-US" dirty="0"/>
+              <a:t>Results</a:t>
+            </a:r>
+          </a:p>
+        </p:txBody>
+      </p:sp>
+      <p:sp>
+        <p:nvSpPr>
+          <p:cNvPr id="3" name="Slide Number Placeholder 2">
+            <a:extLst>
+              <a:ext uri="{FF2B5EF4-FFF2-40B4-BE49-F238E27FC236}">
+                <a16:creationId xmlns:a16="http://schemas.microsoft.com/office/drawing/2014/main" id="{53088EE7-CA55-1F9E-B344-056556A31049}"/>
+              </a:ext>
+            </a:extLst>
+          </p:cNvPr>
+          <p:cNvSpPr>
+            <a:spLocks noGrp="1"/>
+          </p:cNvSpPr>
+          <p:nvPr>
+            <p:ph type="sldNum" sz="quarter" idx="10"/>
+          </p:nvPr>
+        </p:nvSpPr>
+        <p:spPr/>
+        <p:txBody>
+          <a:bodyPr/>
+          <a:lstStyle/>
+          <a:p>
+            <a:fld id="{CAC3FE34-2808-40E6-BEA2-B7CA77D47CA5}" type="slidenum">
+              <a:rPr lang="en-US" smtClean="0"/>
+              <a:pPr/>
+              <a:t>9</a:t>
+            </a:fld>
+            <a:endParaRPr lang="en-US" dirty="0"/>
+          </a:p>
+        </p:txBody>
+      </p:sp>
+      <p:sp>
+        <p:nvSpPr>
+          <p:cNvPr id="4" name="Text Placeholder 3">
+            <a:extLst>
+              <a:ext uri="{FF2B5EF4-FFF2-40B4-BE49-F238E27FC236}">
+                <a16:creationId xmlns:a16="http://schemas.microsoft.com/office/drawing/2014/main" id="{B0B80D4A-A687-AA74-2808-DA47796FCE69}"/>
+              </a:ext>
+            </a:extLst>
+          </p:cNvPr>
+          <p:cNvSpPr>
+            <a:spLocks noGrp="1"/>
+          </p:cNvSpPr>
+          <p:nvPr>
+            <p:ph type="body" sz="quarter" idx="11"/>
+          </p:nvPr>
+        </p:nvSpPr>
+        <p:spPr>
+          <a:xfrm>
+            <a:off x="135540" y="1341438"/>
+            <a:ext cx="4574872" cy="5403009"/>
+          </a:xfrm>
+        </p:spPr>
+        <p:txBody>
+          <a:bodyPr vert="horz" lIns="91440" tIns="45720" rIns="91440" bIns="45720" rtlCol="0" anchor="t">
+            <a:normAutofit/>
+          </a:bodyPr>
+          <a:lstStyle/>
+          <a:p>
+            <a:r>
+              <a:rPr lang="en-US" dirty="0">
+                <a:cs typeface="Arial"/>
+              </a:rPr>
+              <a:t>The predicted residual can closely follow the true residual proving the model can predict the error of the orbit propagation.</a:t>
+            </a:r>
+            <a:endParaRPr lang="en-US" dirty="0"/>
+          </a:p>
+          <a:p>
+            <a:r>
+              <a:rPr lang="en-US" dirty="0">
+                <a:cs typeface="Arial"/>
+              </a:rPr>
+              <a:t>The TDNN-corrected error is consistently lower, reducing the </a:t>
+            </a:r>
+            <a:r>
+              <a:rPr lang="en-US" dirty="0" err="1">
+                <a:cs typeface="Arial"/>
+              </a:rPr>
+              <a:t>varience</a:t>
+            </a:r>
+            <a:r>
+              <a:rPr lang="en-US" dirty="0">
+                <a:cs typeface="Arial"/>
+              </a:rPr>
+              <a:t>, improving the orbit estimation. </a:t>
+            </a:r>
+            <a:endParaRPr lang="en-US" dirty="0"/>
+          </a:p>
+          <a:p>
+            <a:endParaRPr lang="en-US" dirty="0"/>
+          </a:p>
+          <a:p>
+            <a:endParaRPr lang="en-US" dirty="0"/>
+          </a:p>
+        </p:txBody>
+      </p:sp>
+      <p:pic>
+        <p:nvPicPr>
+          <p:cNvPr id="8" name="Picture 7" descr="A graph showing blue and orange lines&#10;&#10;AI-generated content may be incorrect.">
+            <a:extLst>
+              <a:ext uri="{FF2B5EF4-FFF2-40B4-BE49-F238E27FC236}">
+                <a16:creationId xmlns:a16="http://schemas.microsoft.com/office/drawing/2014/main" id="{40F441BD-AC87-C82E-158C-41F0F348FDFF}"/>
+              </a:ext>
+            </a:extLst>
+          </p:cNvPr>
+          <p:cNvPicPr>
+            <a:picLocks noChangeAspect="1"/>
+          </p:cNvPicPr>
+          <p:nvPr/>
+        </p:nvPicPr>
+        <p:blipFill>
+          <a:blip r:embed="rId2">
+            <a:extLst>
+              <a:ext uri="{28A0092B-C50C-407E-A947-70E740481C1C}">
+                <a14:useLocalDpi xmlns:a14="http://schemas.microsoft.com/office/drawing/2010/main" val="0"/>
+              </a:ext>
+            </a:extLst>
+          </a:blip>
+          <a:stretch>
+            <a:fillRect/>
+          </a:stretch>
+        </p:blipFill>
+        <p:spPr>
+          <a:xfrm>
+            <a:off x="4681152" y="4133018"/>
+            <a:ext cx="7375307" cy="2611429"/>
+          </a:xfrm>
+          <a:prstGeom prst="rect">
+            <a:avLst/>
+          </a:prstGeom>
+        </p:spPr>
+      </p:pic>
+      <p:pic>
+        <p:nvPicPr>
+          <p:cNvPr id="6" name="Picture 5" descr="A graph with blue and orange lines&#10;&#10;AI-generated content may be incorrect.">
+            <a:extLst>
+              <a:ext uri="{FF2B5EF4-FFF2-40B4-BE49-F238E27FC236}">
+                <a16:creationId xmlns:a16="http://schemas.microsoft.com/office/drawing/2014/main" id="{E118D0C7-12B9-4826-0F47-068C4F1F354E}"/>
+              </a:ext>
+            </a:extLst>
+          </p:cNvPr>
+          <p:cNvPicPr>
+            <a:picLocks noChangeAspect="1"/>
+          </p:cNvPicPr>
+          <p:nvPr/>
+        </p:nvPicPr>
+        <p:blipFill>
+          <a:blip r:embed="rId3">
+            <a:extLst>
+              <a:ext uri="{28A0092B-C50C-407E-A947-70E740481C1C}">
+                <a14:useLocalDpi xmlns:a14="http://schemas.microsoft.com/office/drawing/2010/main" val="0"/>
+              </a:ext>
+            </a:extLst>
+          </a:blip>
+          <a:stretch>
+            <a:fillRect/>
+          </a:stretch>
+        </p:blipFill>
+        <p:spPr>
+          <a:xfrm>
+            <a:off x="4681152" y="1331975"/>
+            <a:ext cx="7355337" cy="2710967"/>
+          </a:xfrm>
+          <a:prstGeom prst="rect">
+            <a:avLst/>
+          </a:prstGeom>
+        </p:spPr>
+      </p:pic>
+    </p:spTree>
+    <p:extLst>
+      <p:ext uri="{BB962C8B-B14F-4D97-AF65-F5344CB8AC3E}">
+        <p14:creationId xmlns:p14="http://schemas.microsoft.com/office/powerpoint/2010/main" val="3323133510"/>
+      </p:ext>
+    </p:extLst>
+  </p:cSld>
+  <p:clrMapOvr>
+    <a:masterClrMapping/>
+  </p:clrMapOvr>
+  <p:transition spd="med"/>
 </p:sld>
 </file>
 

</xml_diff>